<commit_message>
Update expected output to include full citation hyperlink
</commit_message>
<xml_diff>
--- a/tests/examples/case_01_basic/expected.pptx
+++ b/tests/examples/case_01_basic/expected.pptx
@@ -3934,25 +3934,18 @@
         <a:p>
           <a:pPr algn="l"/>
           <a:r>
-            <a:rPr lang="en-US" b="0" dirty="0"/>
-            <a:t>“</a:t>
-          </a:r>
-          <a:r>
             <a:rPr lang="en-US" b="1" dirty="0">
               <a:hlinkClick xmlns:r="http://schemas.openxmlformats.org/officeDocument/2006/relationships" r:id="rId1"/>
             </a:rPr>
-            <a:t>The gospel is the announcement </a:t>
+            <a:t>“The gospel is the announcement </a:t>
           </a:r>
           <a:r>
             <a:rPr lang="en-US" b="0" dirty="0">
               <a:hlinkClick xmlns:r="http://schemas.openxmlformats.org/officeDocument/2006/relationships" r:id="rId1"/>
             </a:rPr>
-            <a:t>or proclamation of Jesus as the long-awaited Messiah of Israel’s hope who through his life, death, burial, resurrection, and ascension conquers sin and death—personal, systemic—in order to unleash the redemption of God—that is, the kingdom of God, for the transformation of humans and systems.</a:t>
+            <a:t>or proclamation of Jesus as the long-awaited Messiah of Israel’s hope who through his life, death, burial, resurrection, and ascension conquers sin and death—personal, systemic—in order to unleash the redemption of God—that is, the kingdom of God, for the transformation of humans and systems.”(28)</a:t>
           </a:r>
-          <a:r>
-            <a:rPr lang="en-US" b="0" dirty="0"/>
-            <a:t>”(28)</a:t>
-          </a:r>
+          <a:endParaRPr lang="en-US" b="0" dirty="0"/>
         </a:p>
         <a:p>
           <a:pPr algn="l"/>
@@ -4846,14 +4839,10 @@
         <a:p>
           <a:pPr algn="l"/>
           <a:r>
-            <a:rPr lang="en-US" dirty="0"/>
-            <a:t>“</a:t>
-          </a:r>
-          <a:r>
             <a:rPr lang="en-US" dirty="0">
               <a:hlinkClick xmlns:r="http://schemas.openxmlformats.org/officeDocument/2006/relationships" r:id="rId1"/>
             </a:rPr>
-            <a:t>The good </a:t>
+            <a:t>”The good </a:t>
           </a:r>
           <a:r>
             <a:rPr lang="en-US" b="1" dirty="0">
@@ -4877,12 +4866,9 @@
             <a:rPr lang="en-US" dirty="0">
               <a:hlinkClick xmlns:r="http://schemas.openxmlformats.org/officeDocument/2006/relationships" r:id="rId1"/>
             </a:rPr>
-            <a:t>, priest , and king, a catholic ecclesiology, and the future consummation of the kingdom.</a:t>
+            <a:t>, priest , and king, a catholic ecclesiology, and the future consummation of the kingdom.”(63)</a:t>
           </a:r>
-          <a:r>
-            <a:rPr lang="en-US" dirty="0"/>
-            <a:t>”(63)</a:t>
-          </a:r>
+          <a:endParaRPr lang="en-US" dirty="0"/>
         </a:p>
       </dgm:t>
     </dgm:pt>
@@ -5938,8 +5924,10 @@
         <a:p>
           <a:pPr algn="l"/>
           <a:r>
-            <a:rPr lang="en-US" dirty="0"/>
-            <a:t>“</a:t>
+            <a:rPr lang="en-US" dirty="0">
+              <a:hlinkClick xmlns:r="http://schemas.openxmlformats.org/officeDocument/2006/relationships" r:id="rId1"/>
+            </a:rPr>
+            <a:t>”</a:t>
           </a:r>
           <a:r>
             <a:rPr lang="en-US" b="1" dirty="0">
@@ -5951,12 +5939,9 @@
             <a:rPr lang="en-US" dirty="0">
               <a:hlinkClick xmlns:r="http://schemas.openxmlformats.org/officeDocument/2006/relationships" r:id="rId1"/>
             </a:rPr>
-            <a:t>, those who trust in Jesus Christ are saved from the guilt and penalty of their former sins, renewed in God’s image, and empowered by the Holy Spirit to love and serve God and neighbor in true holiness all the remaining days of their lives.</a:t>
+            <a:t>, those who trust in Jesus Christ are saved from the guilt and penalty of their former sins, renewed in God’s image, and empowered by the Holy Spirit to love and serve God and neighbor in true holiness all the remaining days of their lives.”(108)</a:t>
           </a:r>
-          <a:r>
-            <a:rPr lang="en-US" dirty="0"/>
-            <a:t>”(108)</a:t>
-          </a:r>
+          <a:endParaRPr lang="en-US" dirty="0"/>
         </a:p>
         <a:p>
           <a:pPr algn="l"/>
@@ -6530,14 +6515,10 @@
         </a:p>
         <a:p>
           <a:r>
-            <a:rPr lang="en-US" dirty="0"/>
-            <a:t>“</a:t>
-          </a:r>
-          <a:r>
             <a:rPr lang="en-US" dirty="0">
               <a:hlinkClick xmlns:r="http://schemas.openxmlformats.org/officeDocument/2006/relationships" r:id="rId1"/>
             </a:rPr>
-            <a:t>My understanding of the gospel is the good news of Jesus Christ to </a:t>
+            <a:t>”My understanding of the gospel is the good news of Jesus Christ to </a:t>
           </a:r>
           <a:r>
             <a:rPr lang="en-US" b="1" dirty="0">
@@ -6984,14 +6965,10 @@
         </a:p>
         <a:p>
           <a:r>
-            <a:rPr lang="en-US" dirty="0"/>
-            <a:t>“</a:t>
-          </a:r>
-          <a:r>
             <a:rPr lang="en-US" dirty="0">
               <a:hlinkClick xmlns:r="http://schemas.openxmlformats.org/officeDocument/2006/relationships" r:id="rId1"/>
             </a:rPr>
-            <a:t>A Liberation Gospel perspective testifies to God’s present voice and </a:t>
+            <a:t>”A Liberation Gospel perspective testifies to God’s present voice and </a:t>
           </a:r>
           <a:r>
             <a:rPr lang="en-US" b="1" dirty="0">
@@ -7003,11 +6980,13 @@
             <a:rPr lang="en-US" dirty="0">
               <a:hlinkClick xmlns:r="http://schemas.openxmlformats.org/officeDocument/2006/relationships" r:id="rId1"/>
             </a:rPr>
-            <a:t>. Born in poverty yet free, Jesus died the death of an enslaved person. A liberation perspective of the gospel marks Jesus’s social status as one among the oppressed and reads with other ‘non-persons.’</a:t>
+            <a:t>. Born in poverty yet free, Jesus died the death of an enslaved person. A liberation perspective of the gospel marks Jesus’s social status as one among the oppressed and reads with other ‘</a:t>
           </a:r>
           <a:r>
-            <a:rPr lang="en-US" dirty="0"/>
-            <a:t>”</a:t>
+            <a:rPr lang="en-US">
+              <a:hlinkClick xmlns:r="http://schemas.openxmlformats.org/officeDocument/2006/relationships" r:id="rId1"/>
+            </a:rPr>
+            <a:t>non-persons.’”</a:t>
           </a:r>
           <a:endParaRPr lang="en-US" i="1" dirty="0"/>
         </a:p>
@@ -7984,25 +7963,18 @@
             <a:buNone/>
           </a:pPr>
           <a:r>
-            <a:rPr lang="en-US" sz="500" b="0" kern="1200" dirty="0"/>
-            <a:t>“</a:t>
-          </a:r>
-          <a:r>
             <a:rPr lang="en-US" sz="500" b="1" kern="1200" dirty="0">
               <a:hlinkClick xmlns:r="http://schemas.openxmlformats.org/officeDocument/2006/relationships" r:id="rId1"/>
             </a:rPr>
-            <a:t>The gospel is the announcement </a:t>
+            <a:t>“The gospel is the announcement </a:t>
           </a:r>
           <a:r>
             <a:rPr lang="en-US" sz="500" b="0" kern="1200" dirty="0">
               <a:hlinkClick xmlns:r="http://schemas.openxmlformats.org/officeDocument/2006/relationships" r:id="rId1"/>
             </a:rPr>
-            <a:t>or proclamation of Jesus as the long-awaited Messiah of Israel’s hope who through his life, death, burial, resurrection, and ascension conquers sin and death—personal, systemic—in order to unleash the redemption of God—that is, the kingdom of God, for the transformation of humans and systems.</a:t>
+            <a:t>or proclamation of Jesus as the long-awaited Messiah of Israel’s hope who through his life, death, burial, resurrection, and ascension conquers sin and death—personal, systemic—in order to unleash the redemption of God—that is, the kingdom of God, for the transformation of humans and systems.”(28)</a:t>
           </a:r>
-          <a:r>
-            <a:rPr lang="en-US" sz="500" b="0" kern="1200" dirty="0"/>
-            <a:t>”(28)</a:t>
-          </a:r>
+          <a:endParaRPr lang="en-US" sz="500" b="0" kern="1200" dirty="0"/>
         </a:p>
         <a:p>
           <a:pPr marL="0" lvl="0" indent="0" algn="l" defTabSz="222250">
@@ -9398,14 +9370,10 @@
             <a:buNone/>
           </a:pPr>
           <a:r>
-            <a:rPr lang="en-US" sz="600" kern="1200" dirty="0"/>
-            <a:t>“</a:t>
-          </a:r>
-          <a:r>
             <a:rPr lang="en-US" sz="600" kern="1200" dirty="0">
               <a:hlinkClick xmlns:r="http://schemas.openxmlformats.org/officeDocument/2006/relationships" r:id="rId1"/>
             </a:rPr>
-            <a:t>The good </a:t>
+            <a:t>”The good </a:t>
           </a:r>
           <a:r>
             <a:rPr lang="en-US" sz="600" b="1" kern="1200" dirty="0">
@@ -9429,12 +9397,9 @@
             <a:rPr lang="en-US" sz="600" kern="1200" dirty="0">
               <a:hlinkClick xmlns:r="http://schemas.openxmlformats.org/officeDocument/2006/relationships" r:id="rId1"/>
             </a:rPr>
-            <a:t>, priest , and king, a catholic ecclesiology, and the future consummation of the kingdom.</a:t>
+            <a:t>, priest , and king, a catholic ecclesiology, and the future consummation of the kingdom.”(63)</a:t>
           </a:r>
-          <a:r>
-            <a:rPr lang="en-US" sz="600" kern="1200" dirty="0"/>
-            <a:t>”(63)</a:t>
-          </a:r>
+          <a:endParaRPr lang="en-US" sz="600" kern="1200" dirty="0"/>
         </a:p>
       </dsp:txBody>
       <dsp:txXfrm>
@@ -10631,8 +10596,10 @@
             <a:buNone/>
           </a:pPr>
           <a:r>
-            <a:rPr lang="en-US" sz="800" kern="1200" dirty="0"/>
-            <a:t>“</a:t>
+            <a:rPr lang="en-US" sz="800" kern="1200" dirty="0">
+              <a:hlinkClick xmlns:r="http://schemas.openxmlformats.org/officeDocument/2006/relationships" r:id="rId1"/>
+            </a:rPr>
+            <a:t>”</a:t>
           </a:r>
           <a:r>
             <a:rPr lang="en-US" sz="800" b="1" kern="1200" dirty="0">
@@ -10644,12 +10611,9 @@
             <a:rPr lang="en-US" sz="800" kern="1200" dirty="0">
               <a:hlinkClick xmlns:r="http://schemas.openxmlformats.org/officeDocument/2006/relationships" r:id="rId1"/>
             </a:rPr>
-            <a:t>, those who trust in Jesus Christ are saved from the guilt and penalty of their former sins, renewed in God’s image, and empowered by the Holy Spirit to love and serve God and neighbor in true holiness all the remaining days of their lives.</a:t>
+            <a:t>, those who trust in Jesus Christ are saved from the guilt and penalty of their former sins, renewed in God’s image, and empowered by the Holy Spirit to love and serve God and neighbor in true holiness all the remaining days of their lives.”(108)</a:t>
           </a:r>
-          <a:r>
-            <a:rPr lang="en-US" sz="800" kern="1200" dirty="0"/>
-            <a:t>”(108)</a:t>
-          </a:r>
+          <a:endParaRPr lang="en-US" sz="800" kern="1200" dirty="0"/>
         </a:p>
         <a:p>
           <a:pPr marL="0" lvl="0" indent="0" algn="l" defTabSz="355600">
@@ -11381,14 +11345,10 @@
             <a:buNone/>
           </a:pPr>
           <a:r>
-            <a:rPr lang="en-US" sz="700" kern="1200" dirty="0"/>
-            <a:t>“</a:t>
-          </a:r>
-          <a:r>
             <a:rPr lang="en-US" sz="700" kern="1200" dirty="0">
               <a:hlinkClick xmlns:r="http://schemas.openxmlformats.org/officeDocument/2006/relationships" r:id="rId1"/>
             </a:rPr>
-            <a:t>My understanding of the gospel is the good news of Jesus Christ to </a:t>
+            <a:t>”My understanding of the gospel is the good news of Jesus Christ to </a:t>
           </a:r>
           <a:r>
             <a:rPr lang="en-US" sz="700" b="1" kern="1200" dirty="0">
@@ -11979,14 +11939,10 @@
             <a:buNone/>
           </a:pPr>
           <a:r>
-            <a:rPr lang="en-US" sz="900" kern="1200" dirty="0"/>
-            <a:t>“</a:t>
-          </a:r>
-          <a:r>
             <a:rPr lang="en-US" sz="900" kern="1200" dirty="0">
               <a:hlinkClick xmlns:r="http://schemas.openxmlformats.org/officeDocument/2006/relationships" r:id="rId1"/>
             </a:rPr>
-            <a:t>A Liberation Gospel perspective testifies to God’s present voice and </a:t>
+            <a:t>”A Liberation Gospel perspective testifies to God’s present voice and </a:t>
           </a:r>
           <a:r>
             <a:rPr lang="en-US" sz="900" b="1" kern="1200" dirty="0">
@@ -11998,11 +11954,13 @@
             <a:rPr lang="en-US" sz="900" kern="1200" dirty="0">
               <a:hlinkClick xmlns:r="http://schemas.openxmlformats.org/officeDocument/2006/relationships" r:id="rId1"/>
             </a:rPr>
-            <a:t>. Born in poverty yet free, Jesus died the death of an enslaved person. A liberation perspective of the gospel marks Jesus’s social status as one among the oppressed and reads with other ‘non-persons.’</a:t>
+            <a:t>. Born in poverty yet free, Jesus died the death of an enslaved person. A liberation perspective of the gospel marks Jesus’s social status as one among the oppressed and reads with other ‘</a:t>
           </a:r>
           <a:r>
-            <a:rPr lang="en-US" sz="900" kern="1200" dirty="0"/>
-            <a:t>”</a:t>
+            <a:rPr lang="en-US" sz="900" kern="1200">
+              <a:hlinkClick xmlns:r="http://schemas.openxmlformats.org/officeDocument/2006/relationships" r:id="rId1"/>
+            </a:rPr>
+            <a:t>non-persons.’”</a:t>
           </a:r>
           <a:endParaRPr lang="en-US" sz="900" i="1" kern="1200" dirty="0"/>
         </a:p>
@@ -29463,7 +29421,7 @@
           <p:nvPr>
             <p:extLst>
               <p:ext uri="{D42A27DB-BD31-4B8C-83A1-F6EECF244321}">
-                <p14:modId xmlns:p14="http://schemas.microsoft.com/office/powerpoint/2010/main" val="881391306"/>
+                <p14:modId xmlns:p14="http://schemas.microsoft.com/office/powerpoint/2010/main" val="3643715462"/>
               </p:ext>
             </p:extLst>
           </p:nvPr>
@@ -29694,7 +29652,7 @@
           <p:nvPr>
             <p:extLst>
               <p:ext uri="{D42A27DB-BD31-4B8C-83A1-F6EECF244321}">
-                <p14:modId xmlns:p14="http://schemas.microsoft.com/office/powerpoint/2010/main" val="620740049"/>
+                <p14:modId xmlns:p14="http://schemas.microsoft.com/office/powerpoint/2010/main" val="108297262"/>
               </p:ext>
             </p:extLst>
           </p:nvPr>
@@ -29897,7 +29855,7 @@
           <p:nvPr>
             <p:extLst>
               <p:ext uri="{D42A27DB-BD31-4B8C-83A1-F6EECF244321}">
-                <p14:modId xmlns:p14="http://schemas.microsoft.com/office/powerpoint/2010/main" val="2711262926"/>
+                <p14:modId xmlns:p14="http://schemas.microsoft.com/office/powerpoint/2010/main" val="3198722726"/>
               </p:ext>
             </p:extLst>
           </p:nvPr>
@@ -30126,7 +30084,7 @@
           <p:nvPr>
             <p:extLst>
               <p:ext uri="{D42A27DB-BD31-4B8C-83A1-F6EECF244321}">
-                <p14:modId xmlns:p14="http://schemas.microsoft.com/office/powerpoint/2010/main" val="1394842302"/>
+                <p14:modId xmlns:p14="http://schemas.microsoft.com/office/powerpoint/2010/main" val="3249723961"/>
               </p:ext>
             </p:extLst>
           </p:nvPr>
@@ -30218,7 +30176,7 @@
           <p:nvPr>
             <p:extLst>
               <p:ext uri="{D42A27DB-BD31-4B8C-83A1-F6EECF244321}">
-                <p14:modId xmlns:p14="http://schemas.microsoft.com/office/powerpoint/2010/main" val="230347576"/>
+                <p14:modId xmlns:p14="http://schemas.microsoft.com/office/powerpoint/2010/main" val="191574730"/>
               </p:ext>
             </p:extLst>
           </p:nvPr>
@@ -31082,6 +31040,14 @@
 </file>
 
 <file path=customXml/item1.xml><?xml version="1.0" encoding="utf-8"?>
+<p:properties xmlns:p="http://schemas.microsoft.com/office/2006/metadata/properties" xmlns:xsi="http://www.w3.org/2001/XMLSchema-instance" xmlns:pc="http://schemas.microsoft.com/office/infopath/2007/PartnerControls">
+  <documentManagement>
+    <_activity xmlns="cc328e4a-acc5-4db9-8edf-03a7e14d7082" xsi:nil="true"/>
+  </documentManagement>
+</p:properties>
+</file>
+
+<file path=customXml/item2.xml><?xml version="1.0" encoding="utf-8"?>
 <ct:contentTypeSchema xmlns:ct="http://schemas.microsoft.com/office/2006/metadata/contentType" xmlns:ma="http://schemas.microsoft.com/office/2006/metadata/properties/metaAttributes" ct:_="" ma:_="" ma:contentTypeName="Document" ma:contentTypeID="0x0101008E645426CC3C3348B900E57479C898EF" ma:contentTypeVersion="15" ma:contentTypeDescription="Create a new document." ma:contentTypeScope="" ma:versionID="4bc64779f88d1d78707623c1e29ebd00">
   <xsd:schema xmlns:xsd="http://www.w3.org/2001/XMLSchema" xmlns:xs="http://www.w3.org/2001/XMLSchema" xmlns:p="http://schemas.microsoft.com/office/2006/metadata/properties" xmlns:ns3="cc328e4a-acc5-4db9-8edf-03a7e14d7082" xmlns:ns4="5a361508-a8bd-49ac-aae1-a5acde08ec86" targetNamespace="http://schemas.microsoft.com/office/2006/metadata/properties" ma:root="true" ma:fieldsID="3d4d223e92318e0d0dc86e292859e212" ns3:_="" ns4:_="">
     <xsd:import namespace="cc328e4a-acc5-4db9-8edf-03a7e14d7082"/>
@@ -31316,14 +31282,6 @@
 </ct:contentTypeSchema>
 </file>
 
-<file path=customXml/item2.xml><?xml version="1.0" encoding="utf-8"?>
-<p:properties xmlns:p="http://schemas.microsoft.com/office/2006/metadata/properties" xmlns:xsi="http://www.w3.org/2001/XMLSchema-instance" xmlns:pc="http://schemas.microsoft.com/office/infopath/2007/PartnerControls">
-  <documentManagement>
-    <_activity xmlns="cc328e4a-acc5-4db9-8edf-03a7e14d7082" xsi:nil="true"/>
-  </documentManagement>
-</p:properties>
-</file>
-
 <file path=customXml/item3.xml><?xml version="1.0" encoding="utf-8"?>
 <?mso-contentType ?>
 <FormTemplates xmlns="http://schemas.microsoft.com/sharepoint/v3/contenttype/forms">
@@ -31334,6 +31292,18 @@
 </file>
 
 <file path=customXml/itemProps1.xml><?xml version="1.0" encoding="utf-8"?>
+<ds:datastoreItem xmlns:ds="http://schemas.openxmlformats.org/officeDocument/2006/customXml" ds:itemID="{CF4B5514-C2B0-415F-9108-B3264F87DDF2}">
+  <ds:schemaRefs>
+    <ds:schemaRef ds:uri="http://schemas.microsoft.com/office/2006/metadata/properties"/>
+    <ds:schemaRef ds:uri="http://www.w3.org/2000/xmlns/"/>
+    <ds:schemaRef ds:uri="cc328e4a-acc5-4db9-8edf-03a7e14d7082"/>
+    <ds:schemaRef ds:uri="http://www.w3.org/2001/XMLSchema-instance"/>
+    <ds:schemaRef ds:uri="http://schemas.microsoft.com/office/infopath/2007/PartnerControls"/>
+  </ds:schemaRefs>
+</ds:datastoreItem>
+</file>
+
+<file path=customXml/itemProps2.xml><?xml version="1.0" encoding="utf-8"?>
 <ds:datastoreItem xmlns:ds="http://schemas.openxmlformats.org/officeDocument/2006/customXml" ds:itemID="{568CD85B-F839-4F4F-A8A4-47102501B797}">
   <ds:schemaRefs>
     <ds:schemaRef ds:uri="http://schemas.microsoft.com/office/2006/metadata/contentType"/>
@@ -31353,18 +31323,6 @@
 </ds:datastoreItem>
 </file>
 
-<file path=customXml/itemProps2.xml><?xml version="1.0" encoding="utf-8"?>
-<ds:datastoreItem xmlns:ds="http://schemas.openxmlformats.org/officeDocument/2006/customXml" ds:itemID="{CF4B5514-C2B0-415F-9108-B3264F87DDF2}">
-  <ds:schemaRefs>
-    <ds:schemaRef ds:uri="http://schemas.microsoft.com/office/2006/metadata/properties"/>
-    <ds:schemaRef ds:uri="http://www.w3.org/2000/xmlns/"/>
-    <ds:schemaRef ds:uri="cc328e4a-acc5-4db9-8edf-03a7e14d7082"/>
-    <ds:schemaRef ds:uri="http://www.w3.org/2001/XMLSchema-instance"/>
-    <ds:schemaRef ds:uri="http://schemas.microsoft.com/office/infopath/2007/PartnerControls"/>
-  </ds:schemaRefs>
-</ds:datastoreItem>
-</file>
-
 <file path=customXml/itemProps3.xml><?xml version="1.0" encoding="utf-8"?>
 <ds:datastoreItem xmlns:ds="http://schemas.openxmlformats.org/officeDocument/2006/customXml" ds:itemID="{8044CA59-19DA-4472-821C-352737C499D2}">
   <ds:schemaRefs>

</xml_diff>

<commit_message>
Update expected output to include fix in reformation slide
</commit_message>
<xml_diff>
--- a/tests/examples/case_01_basic/expected.pptx
+++ b/tests/examples/case_01_basic/expected.pptx
@@ -4854,17 +4854,27 @@
             <a:rPr lang="en-US" dirty="0">
               <a:hlinkClick xmlns:r="http://schemas.openxmlformats.org/officeDocument/2006/relationships" r:id="rId1"/>
             </a:rPr>
-            <a:t>well” by Rev 5:9-10 which is packed with “</a:t>
+            <a:t>well” </a:t>
+          </a:r>
+          <a:r>
+            <a:rPr lang="en-US" dirty="0"/>
+            <a:t>by Rev 5:9-10 which is packed with </a:t>
+          </a:r>
+          <a:r>
+            <a:rPr lang="en-US" dirty="0">
+              <a:hlinkClick xmlns:r="http://schemas.openxmlformats.org/officeDocument/2006/relationships" r:id="rId2"/>
+            </a:rPr>
+            <a:t>“</a:t>
           </a:r>
           <a:r>
             <a:rPr lang="en-US" b="1" dirty="0">
-              <a:hlinkClick xmlns:r="http://schemas.openxmlformats.org/officeDocument/2006/relationships" r:id="rId1"/>
+              <a:hlinkClick xmlns:r="http://schemas.openxmlformats.org/officeDocument/2006/relationships" r:id="rId2"/>
             </a:rPr>
             <a:t>the person and work of Christ as prophet</a:t>
           </a:r>
           <a:r>
             <a:rPr lang="en-US" dirty="0">
-              <a:hlinkClick xmlns:r="http://schemas.openxmlformats.org/officeDocument/2006/relationships" r:id="rId1"/>
+              <a:hlinkClick xmlns:r="http://schemas.openxmlformats.org/officeDocument/2006/relationships" r:id="rId2"/>
             </a:rPr>
             <a:t>, priest , and king, a catholic ecclesiology, and the future consummation of the kingdom.”(63)</a:t>
           </a:r>
@@ -9385,17 +9395,27 @@
             <a:rPr lang="en-US" sz="600" kern="1200" dirty="0">
               <a:hlinkClick xmlns:r="http://schemas.openxmlformats.org/officeDocument/2006/relationships" r:id="rId1"/>
             </a:rPr>
-            <a:t>well” by Rev 5:9-10 which is packed with “</a:t>
+            <a:t>well” </a:t>
+          </a:r>
+          <a:r>
+            <a:rPr lang="en-US" sz="600" kern="1200" dirty="0"/>
+            <a:t>by Rev 5:9-10 which is packed with </a:t>
+          </a:r>
+          <a:r>
+            <a:rPr lang="en-US" sz="600" kern="1200" dirty="0">
+              <a:hlinkClick xmlns:r="http://schemas.openxmlformats.org/officeDocument/2006/relationships" r:id="rId2"/>
+            </a:rPr>
+            <a:t>“</a:t>
           </a:r>
           <a:r>
             <a:rPr lang="en-US" sz="600" b="1" kern="1200" dirty="0">
-              <a:hlinkClick xmlns:r="http://schemas.openxmlformats.org/officeDocument/2006/relationships" r:id="rId1"/>
+              <a:hlinkClick xmlns:r="http://schemas.openxmlformats.org/officeDocument/2006/relationships" r:id="rId2"/>
             </a:rPr>
             <a:t>the person and work of Christ as prophet</a:t>
           </a:r>
           <a:r>
             <a:rPr lang="en-US" sz="600" kern="1200" dirty="0">
-              <a:hlinkClick xmlns:r="http://schemas.openxmlformats.org/officeDocument/2006/relationships" r:id="rId1"/>
+              <a:hlinkClick xmlns:r="http://schemas.openxmlformats.org/officeDocument/2006/relationships" r:id="rId2"/>
             </a:rPr>
             <a:t>, priest , and king, a catholic ecclesiology, and the future consummation of the kingdom.”(63)</a:t>
           </a:r>
@@ -29652,7 +29672,7 @@
           <p:nvPr>
             <p:extLst>
               <p:ext uri="{D42A27DB-BD31-4B8C-83A1-F6EECF244321}">
-                <p14:modId xmlns:p14="http://schemas.microsoft.com/office/powerpoint/2010/main" val="108297262"/>
+                <p14:modId xmlns:p14="http://schemas.microsoft.com/office/powerpoint/2010/main" val="796254607"/>
               </p:ext>
             </p:extLst>
           </p:nvPr>
@@ -31040,14 +31060,6 @@
 </file>
 
 <file path=customXml/item1.xml><?xml version="1.0" encoding="utf-8"?>
-<p:properties xmlns:p="http://schemas.microsoft.com/office/2006/metadata/properties" xmlns:xsi="http://www.w3.org/2001/XMLSchema-instance" xmlns:pc="http://schemas.microsoft.com/office/infopath/2007/PartnerControls">
-  <documentManagement>
-    <_activity xmlns="cc328e4a-acc5-4db9-8edf-03a7e14d7082" xsi:nil="true"/>
-  </documentManagement>
-</p:properties>
-</file>
-
-<file path=customXml/item2.xml><?xml version="1.0" encoding="utf-8"?>
 <ct:contentTypeSchema xmlns:ct="http://schemas.microsoft.com/office/2006/metadata/contentType" xmlns:ma="http://schemas.microsoft.com/office/2006/metadata/properties/metaAttributes" ct:_="" ma:_="" ma:contentTypeName="Document" ma:contentTypeID="0x0101008E645426CC3C3348B900E57479C898EF" ma:contentTypeVersion="15" ma:contentTypeDescription="Create a new document." ma:contentTypeScope="" ma:versionID="4bc64779f88d1d78707623c1e29ebd00">
   <xsd:schema xmlns:xsd="http://www.w3.org/2001/XMLSchema" xmlns:xs="http://www.w3.org/2001/XMLSchema" xmlns:p="http://schemas.microsoft.com/office/2006/metadata/properties" xmlns:ns3="cc328e4a-acc5-4db9-8edf-03a7e14d7082" xmlns:ns4="5a361508-a8bd-49ac-aae1-a5acde08ec86" targetNamespace="http://schemas.microsoft.com/office/2006/metadata/properties" ma:root="true" ma:fieldsID="3d4d223e92318e0d0dc86e292859e212" ns3:_="" ns4:_="">
     <xsd:import namespace="cc328e4a-acc5-4db9-8edf-03a7e14d7082"/>
@@ -31282,6 +31294,14 @@
 </ct:contentTypeSchema>
 </file>
 
+<file path=customXml/item2.xml><?xml version="1.0" encoding="utf-8"?>
+<p:properties xmlns:p="http://schemas.microsoft.com/office/2006/metadata/properties" xmlns:xsi="http://www.w3.org/2001/XMLSchema-instance" xmlns:pc="http://schemas.microsoft.com/office/infopath/2007/PartnerControls">
+  <documentManagement>
+    <_activity xmlns="cc328e4a-acc5-4db9-8edf-03a7e14d7082" xsi:nil="true"/>
+  </documentManagement>
+</p:properties>
+</file>
+
 <file path=customXml/item3.xml><?xml version="1.0" encoding="utf-8"?>
 <?mso-contentType ?>
 <FormTemplates xmlns="http://schemas.microsoft.com/sharepoint/v3/contenttype/forms">
@@ -31292,18 +31312,6 @@
 </file>
 
 <file path=customXml/itemProps1.xml><?xml version="1.0" encoding="utf-8"?>
-<ds:datastoreItem xmlns:ds="http://schemas.openxmlformats.org/officeDocument/2006/customXml" ds:itemID="{CF4B5514-C2B0-415F-9108-B3264F87DDF2}">
-  <ds:schemaRefs>
-    <ds:schemaRef ds:uri="http://schemas.microsoft.com/office/2006/metadata/properties"/>
-    <ds:schemaRef ds:uri="http://www.w3.org/2000/xmlns/"/>
-    <ds:schemaRef ds:uri="cc328e4a-acc5-4db9-8edf-03a7e14d7082"/>
-    <ds:schemaRef ds:uri="http://www.w3.org/2001/XMLSchema-instance"/>
-    <ds:schemaRef ds:uri="http://schemas.microsoft.com/office/infopath/2007/PartnerControls"/>
-  </ds:schemaRefs>
-</ds:datastoreItem>
-</file>
-
-<file path=customXml/itemProps2.xml><?xml version="1.0" encoding="utf-8"?>
 <ds:datastoreItem xmlns:ds="http://schemas.openxmlformats.org/officeDocument/2006/customXml" ds:itemID="{568CD85B-F839-4F4F-A8A4-47102501B797}">
   <ds:schemaRefs>
     <ds:schemaRef ds:uri="http://schemas.microsoft.com/office/2006/metadata/contentType"/>
@@ -31323,6 +31331,18 @@
 </ds:datastoreItem>
 </file>
 
+<file path=customXml/itemProps2.xml><?xml version="1.0" encoding="utf-8"?>
+<ds:datastoreItem xmlns:ds="http://schemas.openxmlformats.org/officeDocument/2006/customXml" ds:itemID="{CF4B5514-C2B0-415F-9108-B3264F87DDF2}">
+  <ds:schemaRefs>
+    <ds:schemaRef ds:uri="http://schemas.microsoft.com/office/2006/metadata/properties"/>
+    <ds:schemaRef ds:uri="http://www.w3.org/2000/xmlns/"/>
+    <ds:schemaRef ds:uri="cc328e4a-acc5-4db9-8edf-03a7e14d7082"/>
+    <ds:schemaRef ds:uri="http://www.w3.org/2001/XMLSchema-instance"/>
+    <ds:schemaRef ds:uri="http://schemas.microsoft.com/office/infopath/2007/PartnerControls"/>
+  </ds:schemaRefs>
+</ds:datastoreItem>
+</file>
+
 <file path=customXml/itemProps3.xml><?xml version="1.0" encoding="utf-8"?>
 <ds:datastoreItem xmlns:ds="http://schemas.openxmlformats.org/officeDocument/2006/customXml" ds:itemID="{8044CA59-19DA-4472-821C-352737C499D2}">
   <ds:schemaRefs>

</xml_diff>

<commit_message>
Correct basic quote-link fixtures
</commit_message>
<xml_diff>
--- a/tests/examples/case_01_basic/expected.pptx
+++ b/tests/examples/case_01_basic/expected.pptx
@@ -4916,18 +4916,30 @@
           <a:pPr algn="l"/>
           <a:r>
             <a:rPr lang="en-US" dirty="0"/>
-            <a:t>For Reformers “</a:t>
+            <a:t>For Reformers </a:t>
           </a:r>
           <a:r>
-            <a:rPr lang="en-US" b="1" dirty="0"/>
+            <a:rPr lang="en-US" dirty="0">
+              <a:hlinkClick xmlns:r="http://schemas.openxmlformats.org/officeDocument/2006/relationships" r:id="rId3"/>
+            </a:rPr>
+            <a:t>“</a:t>
+          </a:r>
+          <a:r>
+            <a:rPr lang="en-US" b="1" dirty="0">
+              <a:hlinkClick xmlns:r="http://schemas.openxmlformats.org/officeDocument/2006/relationships" r:id="rId3"/>
+            </a:rPr>
             <a:t>the work of Christ has been treated under the </a:t>
           </a:r>
           <a:r>
-            <a:rPr lang="en-US" dirty="0"/>
+            <a:rPr lang="en-US" dirty="0">
+              <a:hlinkClick xmlns:r="http://schemas.openxmlformats.org/officeDocument/2006/relationships" r:id="rId3"/>
+            </a:rPr>
             <a:t>integrative rubric of prophet, priest and king” (64, par. 1)</a:t>
           </a:r>
           <a:br>
-            <a:rPr lang="en-US" dirty="0"/>
+            <a:rPr lang="en-US" dirty="0">
+              <a:hlinkClick xmlns:r="http://schemas.openxmlformats.org/officeDocument/2006/relationships" r:id="rId3"/>
+            </a:rPr>
           </a:br>
           <a:r>
             <a:rPr lang="en-US" dirty="0"/>
@@ -4976,15 +4988,21 @@
         <a:p>
           <a:pPr algn="l"/>
           <a:r>
-            <a:rPr lang="en-US" dirty="0"/>
+            <a:rPr lang="en-US" dirty="0">
+              <a:hlinkClick xmlns:r="http://schemas.openxmlformats.org/officeDocument/2006/relationships" r:id="rId4"/>
+            </a:rPr>
             <a:t>“</a:t>
           </a:r>
           <a:r>
-            <a:rPr lang="en-US" b="1" dirty="0"/>
+            <a:rPr lang="en-US" b="1" dirty="0">
+              <a:hlinkClick xmlns:r="http://schemas.openxmlformats.org/officeDocument/2006/relationships" r:id="rId4"/>
+            </a:rPr>
             <a:t>Alternatives to the so-called </a:t>
           </a:r>
           <a:r>
-            <a:rPr lang="en-US" dirty="0"/>
+            <a:rPr lang="en-US" dirty="0">
+              <a:hlinkClick xmlns:r="http://schemas.openxmlformats.org/officeDocument/2006/relationships" r:id="rId4"/>
+            </a:rPr>
             <a:t>Reformation Gospel are reductionistic in their view of the plight and solution”(65, par.2) </a:t>
           </a:r>
           <a:br>
@@ -5031,16 +5049,27 @@
           <a:pPr algn="l"/>
           <a:r>
             <a:rPr lang="en-US" dirty="0"/>
-            <a:t>Calvin: “</a:t>
+            <a:t>Calvin: </a:t>
           </a:r>
           <a:r>
-            <a:rPr lang="en-US" b="1" dirty="0"/>
+            <a:rPr lang="en-US" dirty="0">
+              <a:hlinkClick xmlns:r="http://schemas.openxmlformats.org/officeDocument/2006/relationships" r:id="rId5"/>
+            </a:rPr>
+            <a:t>“</a:t>
+          </a:r>
+          <a:r>
+            <a:rPr lang="en-US" b="1" dirty="0">
+              <a:hlinkClick xmlns:r="http://schemas.openxmlformats.org/officeDocument/2006/relationships" r:id="rId5"/>
+            </a:rPr>
             <a:t>We see that our whole salvation </a:t>
           </a:r>
           <a:r>
-            <a:rPr lang="en-US" dirty="0"/>
+            <a:rPr lang="en-US" dirty="0">
+              <a:hlinkClick xmlns:r="http://schemas.openxmlformats.org/officeDocument/2006/relationships" r:id="rId5"/>
+            </a:rPr>
             <a:t>and all its part are comprehended in Christ” (64, par.3)</a:t>
           </a:r>
+          <a:endParaRPr lang="en-US" dirty="0"/>
         </a:p>
       </dgm:t>
     </dgm:pt>
@@ -5076,23 +5105,33 @@
         <a:p>
           <a:pPr algn="l"/>
           <a:r>
-            <a:rPr lang="en-US" dirty="0"/>
+            <a:rPr lang="en-US" dirty="0">
+              <a:hlinkClick xmlns:r="http://schemas.openxmlformats.org/officeDocument/2006/relationships" r:id="rId6"/>
+            </a:rPr>
             <a:t>“The </a:t>
           </a:r>
           <a:r>
-            <a:rPr lang="en-US" b="1" dirty="0"/>
+            <a:rPr lang="en-US" b="1" dirty="0">
+              <a:hlinkClick xmlns:r="http://schemas.openxmlformats.org/officeDocument/2006/relationships" r:id="rId6"/>
+            </a:rPr>
             <a:t>curse resulting from the fall </a:t>
           </a:r>
           <a:r>
-            <a:rPr lang="en-US" dirty="0"/>
+            <a:rPr lang="en-US" dirty="0">
+              <a:hlinkClick xmlns:r="http://schemas.openxmlformats.org/officeDocument/2006/relationships" r:id="rId6"/>
+            </a:rPr>
             <a:t>is all-</a:t>
           </a:r>
           <a:r>
-            <a:rPr lang="en-US" dirty="0" err="1"/>
+            <a:rPr lang="en-US" dirty="0" err="1">
+              <a:hlinkClick xmlns:r="http://schemas.openxmlformats.org/officeDocument/2006/relationships" r:id="rId6"/>
+            </a:rPr>
             <a:t>emcompassing</a:t>
           </a:r>
           <a:r>
-            <a:rPr lang="en-US" dirty="0"/>
+            <a:rPr lang="en-US" dirty="0">
+              <a:hlinkClick xmlns:r="http://schemas.openxmlformats.org/officeDocument/2006/relationships" r:id="rId6"/>
+            </a:rPr>
             <a:t>” (65, par. 3)</a:t>
           </a:r>
           <a:br>
@@ -5138,25 +5177,24 @@
         <a:p>
           <a:pPr algn="l"/>
           <a:r>
-            <a:rPr lang="en-US" dirty="0"/>
+            <a:rPr lang="en-US" dirty="0">
+              <a:hlinkClick xmlns:r="http://schemas.openxmlformats.org/officeDocument/2006/relationships" r:id="rId7"/>
+            </a:rPr>
             <a:t>“</a:t>
           </a:r>
           <a:r>
-            <a:rPr lang="en-US" b="1" dirty="0"/>
-            <a:t>Christ himself is the </a:t>
+            <a:rPr lang="en-US" b="1" dirty="0">
+              <a:hlinkClick xmlns:r="http://schemas.openxmlformats.org/officeDocument/2006/relationships" r:id="rId7"/>
+            </a:rPr>
+            <a:t>Christ himself is the solution </a:t>
           </a:r>
           <a:r>
-            <a:rPr lang="en-US" b="1"/>
-            <a:t>solution </a:t>
+            <a:rPr lang="en-US" dirty="0">
+              <a:hlinkClick xmlns:r="http://schemas.openxmlformats.org/officeDocument/2006/relationships" r:id="rId7"/>
+            </a:rPr>
+            <a:t>the extensiveness of the curse”(66, par. 12)</a:t>
           </a:r>
-          <a:r>
-            <a:rPr lang="en-US"/>
-            <a:t>the </a:t>
-          </a:r>
-          <a:r>
-            <a:rPr lang="en-US" dirty="0"/>
-            <a:t>extensiveness of the curse”(66, par. 12)</a:t>
-          </a:r>
+          <a:endParaRPr lang="en-US" dirty="0"/>
         </a:p>
       </dgm:t>
     </dgm:pt>
@@ -5192,15 +5230,21 @@
         <a:p>
           <a:pPr algn="l"/>
           <a:r>
-            <a:rPr lang="en-US" dirty="0"/>
+            <a:rPr lang="en-US" dirty="0">
+              <a:hlinkClick xmlns:r="http://schemas.openxmlformats.org/officeDocument/2006/relationships" r:id="rId8"/>
+            </a:rPr>
             <a:t>“However, </a:t>
           </a:r>
           <a:r>
-            <a:rPr lang="en-US" b="1" dirty="0"/>
+            <a:rPr lang="en-US" b="1" dirty="0">
+              <a:hlinkClick xmlns:r="http://schemas.openxmlformats.org/officeDocument/2006/relationships" r:id="rId8"/>
+            </a:rPr>
             <a:t>apart from the justification of the ungodly</a:t>
           </a:r>
           <a:r>
-            <a:rPr lang="en-US" dirty="0"/>
+            <a:rPr lang="en-US" dirty="0">
+              <a:hlinkClick xmlns:r="http://schemas.openxmlformats.org/officeDocument/2006/relationships" r:id="rId8"/>
+            </a:rPr>
             <a:t>, even the most majestic facets become condemning law for me as a sinner”(67, par. 2)</a:t>
           </a:r>
           <a:br>
@@ -6003,17 +6047,24 @@
         <a:p>
           <a:pPr algn="l"/>
           <a:r>
-            <a:rPr lang="en-US" i="0" dirty="0"/>
+            <a:rPr lang="en-US" i="0" dirty="0">
+              <a:hlinkClick xmlns:r="http://schemas.openxmlformats.org/officeDocument/2006/relationships" r:id="rId2"/>
+            </a:rPr>
             <a:t>“ his[Wesley’s] ministers should ‘</a:t>
           </a:r>
           <a:r>
-            <a:rPr lang="en-US" b="1" i="0" dirty="0"/>
+            <a:rPr lang="en-US" b="1" i="0" dirty="0">
+              <a:hlinkClick xmlns:r="http://schemas.openxmlformats.org/officeDocument/2006/relationships" r:id="rId2"/>
+            </a:rPr>
             <a:t>preach the whole gospel</a:t>
           </a:r>
           <a:r>
-            <a:rPr lang="en-US" i="0" dirty="0"/>
+            <a:rPr lang="en-US" i="0" dirty="0">
+              <a:hlinkClick xmlns:r="http://schemas.openxmlformats.org/officeDocument/2006/relationships" r:id="rId2"/>
+            </a:rPr>
             <a:t>, even justification and sanctification, preparatory to glory,’”</a:t>
           </a:r>
+          <a:endParaRPr lang="en-US" i="0" dirty="0"/>
         </a:p>
         <a:p>
           <a:pPr algn="l"/>
@@ -6058,10 +6109,18 @@
           <a:pPr algn="l"/>
           <a:r>
             <a:rPr lang="en-US" dirty="0"/>
-            <a:t>The gospel announces deliverance from two problems: “</a:t>
+            <a:t>The gospel announces deliverance from two problems: </a:t>
           </a:r>
           <a:r>
-            <a:rPr lang="en-US" b="1" dirty="0"/>
+            <a:rPr lang="en-US" dirty="0">
+              <a:hlinkClick xmlns:r="http://schemas.openxmlformats.org/officeDocument/2006/relationships" r:id="rId3"/>
+            </a:rPr>
+            <a:t>“</a:t>
+          </a:r>
+          <a:r>
+            <a:rPr lang="en-US" b="1" dirty="0">
+              <a:hlinkClick xmlns:r="http://schemas.openxmlformats.org/officeDocument/2006/relationships" r:id="rId3"/>
+            </a:rPr>
             <a:t>alienation from the life of God</a:t>
           </a:r>
           <a:r>
@@ -6081,32 +6140,61 @@
           <a:pPr algn="l"/>
           <a:r>
             <a:rPr lang="en-US" dirty="0"/>
-            <a:t>The solution is justification: “</a:t>
+            <a:t>The solution is justification: </a:t>
           </a:r>
           <a:r>
-            <a:rPr lang="en-US" b="1" dirty="0"/>
+            <a:rPr lang="en-US" dirty="0">
+              <a:hlinkClick xmlns:r="http://schemas.openxmlformats.org/officeDocument/2006/relationships" r:id="rId4"/>
+            </a:rPr>
+            <a:t>“</a:t>
+          </a:r>
+          <a:r>
+            <a:rPr lang="en-US" b="1" dirty="0">
+              <a:hlinkClick xmlns:r="http://schemas.openxmlformats.org/officeDocument/2006/relationships" r:id="rId4"/>
+            </a:rPr>
             <a:t>saved from the guilt of sin</a:t>
           </a:r>
           <a:r>
-            <a:rPr lang="en-US" dirty="0"/>
+            <a:rPr lang="en-US" dirty="0">
+              <a:hlinkClick xmlns:r="http://schemas.openxmlformats.org/officeDocument/2006/relationships" r:id="rId4"/>
+            </a:rPr>
             <a:t> and restored to the </a:t>
           </a:r>
           <a:r>
-            <a:rPr lang="en-US" dirty="0" err="1"/>
+            <a:rPr lang="en-US" dirty="0" err="1">
+              <a:hlinkClick xmlns:r="http://schemas.openxmlformats.org/officeDocument/2006/relationships" r:id="rId4"/>
+            </a:rPr>
             <a:t>favour</a:t>
           </a:r>
           <a:r>
-            <a:rPr lang="en-US" dirty="0"/>
-            <a:t> of God” and sanctification: “</a:t>
+            <a:rPr lang="en-US" dirty="0">
+              <a:hlinkClick xmlns:r="http://schemas.openxmlformats.org/officeDocument/2006/relationships" r:id="rId4"/>
+            </a:rPr>
+            <a:t> of God” </a:t>
           </a:r>
           <a:r>
-            <a:rPr lang="en-US" b="1" dirty="0"/>
+            <a:rPr lang="en-US" dirty="0"/>
+            <a:t>and sanctification: </a:t>
+          </a:r>
+          <a:r>
+            <a:rPr lang="en-US" dirty="0">
+              <a:hlinkClick xmlns:r="http://schemas.openxmlformats.org/officeDocument/2006/relationships" r:id="rId5"/>
+            </a:rPr>
+            <a:t>“</a:t>
+          </a:r>
+          <a:r>
+            <a:rPr lang="en-US" b="1" dirty="0">
+              <a:hlinkClick xmlns:r="http://schemas.openxmlformats.org/officeDocument/2006/relationships" r:id="rId5"/>
+            </a:rPr>
             <a:t>saved from the power and root </a:t>
           </a:r>
           <a:r>
-            <a:rPr lang="en-US" dirty="0"/>
+            <a:rPr lang="en-US" dirty="0">
+              <a:hlinkClick xmlns:r="http://schemas.openxmlformats.org/officeDocument/2006/relationships" r:id="rId5"/>
+            </a:rPr>
             <a:t>of sin, and restored to the image of God”.</a:t>
           </a:r>
+          <a:endParaRPr lang="en-US" dirty="0"/>
         </a:p>
       </dgm:t>
     </dgm:pt>
@@ -6143,16 +6231,27 @@
           <a:pPr algn="l"/>
           <a:r>
             <a:rPr lang="en-US" dirty="0"/>
-            <a:t> “Salvation involves the work both of the Son and Holy Spirit, the Son in ‘giving himself to be ‘</a:t>
+            <a:t> </a:t>
           </a:r>
           <a:r>
-            <a:rPr lang="en-US" b="1" dirty="0"/>
+            <a:rPr lang="en-US" dirty="0">
+              <a:hlinkClick xmlns:r="http://schemas.openxmlformats.org/officeDocument/2006/relationships" r:id="rId6"/>
+            </a:rPr>
+            <a:t>“Salvation involves the work both of the Son and Holy Spirit, the Son in ‘giving himself to be ‘</a:t>
+          </a:r>
+          <a:r>
+            <a:rPr lang="en-US" b="1" dirty="0">
+              <a:hlinkClick xmlns:r="http://schemas.openxmlformats.org/officeDocument/2006/relationships" r:id="rId6"/>
+            </a:rPr>
             <a:t>a propitiation for the sins of the world</a:t>
           </a:r>
           <a:r>
-            <a:rPr lang="en-US" dirty="0"/>
+            <a:rPr lang="en-US" dirty="0">
+              <a:hlinkClick xmlns:r="http://schemas.openxmlformats.org/officeDocument/2006/relationships" r:id="rId6"/>
+            </a:rPr>
             <a:t>,’ ‘ the Holy Spirit in ‘renewing men in that image of God wherein they were created”</a:t>
           </a:r>
+          <a:endParaRPr lang="en-US" dirty="0"/>
         </a:p>
       </dgm:t>
     </dgm:pt>
@@ -6188,15 +6287,21 @@
         <a:p>
           <a:pPr algn="l"/>
           <a:r>
-            <a:rPr lang="en-US" dirty="0"/>
+            <a:rPr lang="en-US" dirty="0">
+              <a:hlinkClick xmlns:r="http://schemas.openxmlformats.org/officeDocument/2006/relationships" r:id="rId7"/>
+            </a:rPr>
             <a:t>“John Wesley’s </a:t>
           </a:r>
           <a:r>
-            <a:rPr lang="en-US" b="1" dirty="0"/>
+            <a:rPr lang="en-US" b="1" dirty="0">
+              <a:hlinkClick xmlns:r="http://schemas.openxmlformats.org/officeDocument/2006/relationships" r:id="rId7"/>
+            </a:rPr>
             <a:t>spiritual biography constitutes </a:t>
           </a:r>
           <a:r>
-            <a:rPr lang="en-US" dirty="0"/>
+            <a:rPr lang="en-US" dirty="0">
+              <a:hlinkClick xmlns:r="http://schemas.openxmlformats.org/officeDocument/2006/relationships" r:id="rId7"/>
+            </a:rPr>
             <a:t>one important context for the emergence of his understanding of the gospel.”</a:t>
           </a:r>
           <a:br>
@@ -9495,18 +9600,30 @@
           </a:pPr>
           <a:r>
             <a:rPr lang="en-US" sz="600" kern="1200" dirty="0"/>
-            <a:t>For Reformers “</a:t>
+            <a:t>For Reformers </a:t>
           </a:r>
           <a:r>
-            <a:rPr lang="en-US" sz="600" b="1" kern="1200" dirty="0"/>
+            <a:rPr lang="en-US" sz="600" kern="1200" dirty="0">
+              <a:hlinkClick xmlns:r="http://schemas.openxmlformats.org/officeDocument/2006/relationships" r:id="rId3"/>
+            </a:rPr>
+            <a:t>“</a:t>
+          </a:r>
+          <a:r>
+            <a:rPr lang="en-US" sz="600" b="1" kern="1200" dirty="0">
+              <a:hlinkClick xmlns:r="http://schemas.openxmlformats.org/officeDocument/2006/relationships" r:id="rId3"/>
+            </a:rPr>
             <a:t>the work of Christ has been treated under the </a:t>
           </a:r>
           <a:r>
-            <a:rPr lang="en-US" sz="600" kern="1200" dirty="0"/>
+            <a:rPr lang="en-US" sz="600" kern="1200" dirty="0">
+              <a:hlinkClick xmlns:r="http://schemas.openxmlformats.org/officeDocument/2006/relationships" r:id="rId3"/>
+            </a:rPr>
             <a:t>integrative rubric of prophet, priest and king” (64, par. 1)</a:t>
           </a:r>
           <a:br>
-            <a:rPr lang="en-US" sz="600" kern="1200" dirty="0"/>
+            <a:rPr lang="en-US" sz="600" kern="1200" dirty="0">
+              <a:hlinkClick xmlns:r="http://schemas.openxmlformats.org/officeDocument/2006/relationships" r:id="rId3"/>
+            </a:rPr>
           </a:br>
           <a:r>
             <a:rPr lang="en-US" sz="600" kern="1200" dirty="0"/>
@@ -9594,16 +9711,27 @@
           </a:pPr>
           <a:r>
             <a:rPr lang="en-US" sz="600" kern="1200" dirty="0"/>
-            <a:t>Calvin: “</a:t>
+            <a:t>Calvin: </a:t>
           </a:r>
           <a:r>
-            <a:rPr lang="en-US" sz="600" b="1" kern="1200" dirty="0"/>
+            <a:rPr lang="en-US" sz="600" kern="1200" dirty="0">
+              <a:hlinkClick xmlns:r="http://schemas.openxmlformats.org/officeDocument/2006/relationships" r:id="rId4"/>
+            </a:rPr>
+            <a:t>“</a:t>
+          </a:r>
+          <a:r>
+            <a:rPr lang="en-US" sz="600" b="1" kern="1200" dirty="0">
+              <a:hlinkClick xmlns:r="http://schemas.openxmlformats.org/officeDocument/2006/relationships" r:id="rId4"/>
+            </a:rPr>
             <a:t>We see that our whole salvation </a:t>
           </a:r>
           <a:r>
-            <a:rPr lang="en-US" sz="600" kern="1200" dirty="0"/>
+            <a:rPr lang="en-US" sz="600" kern="1200" dirty="0">
+              <a:hlinkClick xmlns:r="http://schemas.openxmlformats.org/officeDocument/2006/relationships" r:id="rId4"/>
+            </a:rPr>
             <a:t>and all its part are comprehended in Christ” (64, par.3)</a:t>
           </a:r>
+          <a:endParaRPr lang="en-US" sz="600" kern="1200" dirty="0"/>
         </a:p>
       </dsp:txBody>
       <dsp:txXfrm>
@@ -9678,15 +9806,21 @@
             <a:buNone/>
           </a:pPr>
           <a:r>
-            <a:rPr lang="en-US" sz="600" kern="1200" dirty="0"/>
+            <a:rPr lang="en-US" sz="600" kern="1200" dirty="0">
+              <a:hlinkClick xmlns:r="http://schemas.openxmlformats.org/officeDocument/2006/relationships" r:id="rId5"/>
+            </a:rPr>
             <a:t>“</a:t>
           </a:r>
           <a:r>
-            <a:rPr lang="en-US" sz="600" b="1" kern="1200" dirty="0"/>
+            <a:rPr lang="en-US" sz="600" b="1" kern="1200" dirty="0">
+              <a:hlinkClick xmlns:r="http://schemas.openxmlformats.org/officeDocument/2006/relationships" r:id="rId5"/>
+            </a:rPr>
             <a:t>Alternatives to the so-called </a:t>
           </a:r>
           <a:r>
-            <a:rPr lang="en-US" sz="600" kern="1200" dirty="0"/>
+            <a:rPr lang="en-US" sz="600" kern="1200" dirty="0">
+              <a:hlinkClick xmlns:r="http://schemas.openxmlformats.org/officeDocument/2006/relationships" r:id="rId5"/>
+            </a:rPr>
             <a:t>Reformation Gospel are reductionistic in their view of the plight and solution”(65, par.2) </a:t>
           </a:r>
           <a:br>
@@ -9771,23 +9905,33 @@
             <a:buNone/>
           </a:pPr>
           <a:r>
-            <a:rPr lang="en-US" sz="600" kern="1200" dirty="0"/>
+            <a:rPr lang="en-US" sz="600" kern="1200" dirty="0">
+              <a:hlinkClick xmlns:r="http://schemas.openxmlformats.org/officeDocument/2006/relationships" r:id="rId6"/>
+            </a:rPr>
             <a:t>“The </a:t>
           </a:r>
           <a:r>
-            <a:rPr lang="en-US" sz="600" b="1" kern="1200" dirty="0"/>
+            <a:rPr lang="en-US" sz="600" b="1" kern="1200" dirty="0">
+              <a:hlinkClick xmlns:r="http://schemas.openxmlformats.org/officeDocument/2006/relationships" r:id="rId6"/>
+            </a:rPr>
             <a:t>curse resulting from the fall </a:t>
           </a:r>
           <a:r>
-            <a:rPr lang="en-US" sz="600" kern="1200" dirty="0"/>
+            <a:rPr lang="en-US" sz="600" kern="1200" dirty="0">
+              <a:hlinkClick xmlns:r="http://schemas.openxmlformats.org/officeDocument/2006/relationships" r:id="rId6"/>
+            </a:rPr>
             <a:t>is all-</a:t>
           </a:r>
           <a:r>
-            <a:rPr lang="en-US" sz="600" kern="1200" dirty="0" err="1"/>
+            <a:rPr lang="en-US" sz="600" kern="1200" dirty="0" err="1">
+              <a:hlinkClick xmlns:r="http://schemas.openxmlformats.org/officeDocument/2006/relationships" r:id="rId6"/>
+            </a:rPr>
             <a:t>emcompassing</a:t>
           </a:r>
           <a:r>
-            <a:rPr lang="en-US" sz="600" kern="1200" dirty="0"/>
+            <a:rPr lang="en-US" sz="600" kern="1200" dirty="0">
+              <a:hlinkClick xmlns:r="http://schemas.openxmlformats.org/officeDocument/2006/relationships" r:id="rId6"/>
+            </a:rPr>
             <a:t>” (65, par. 3)</a:t>
           </a:r>
           <a:br>
@@ -9872,25 +10016,24 @@
             <a:buNone/>
           </a:pPr>
           <a:r>
-            <a:rPr lang="en-US" sz="600" kern="1200" dirty="0"/>
+            <a:rPr lang="en-US" sz="600" kern="1200" dirty="0">
+              <a:hlinkClick xmlns:r="http://schemas.openxmlformats.org/officeDocument/2006/relationships" r:id="rId7"/>
+            </a:rPr>
             <a:t>“</a:t>
           </a:r>
           <a:r>
-            <a:rPr lang="en-US" sz="600" b="1" kern="1200" dirty="0"/>
-            <a:t>Christ himself is the </a:t>
+            <a:rPr lang="en-US" sz="600" b="1" kern="1200" dirty="0">
+              <a:hlinkClick xmlns:r="http://schemas.openxmlformats.org/officeDocument/2006/relationships" r:id="rId7"/>
+            </a:rPr>
+            <a:t>Christ himself is the solution </a:t>
           </a:r>
           <a:r>
-            <a:rPr lang="en-US" sz="600" b="1" kern="1200"/>
-            <a:t>solution </a:t>
+            <a:rPr lang="en-US" sz="600" kern="1200" dirty="0">
+              <a:hlinkClick xmlns:r="http://schemas.openxmlformats.org/officeDocument/2006/relationships" r:id="rId7"/>
+            </a:rPr>
+            <a:t>the extensiveness of the curse”(66, par. 12)</a:t>
           </a:r>
-          <a:r>
-            <a:rPr lang="en-US" sz="600" kern="1200"/>
-            <a:t>the </a:t>
-          </a:r>
-          <a:r>
-            <a:rPr lang="en-US" sz="600" kern="1200" dirty="0"/>
-            <a:t>extensiveness of the curse”(66, par. 12)</a:t>
-          </a:r>
+          <a:endParaRPr lang="en-US" sz="600" kern="1200" dirty="0"/>
         </a:p>
       </dsp:txBody>
       <dsp:txXfrm>
@@ -9965,15 +10108,21 @@
             <a:buNone/>
           </a:pPr>
           <a:r>
-            <a:rPr lang="en-US" sz="600" kern="1200" dirty="0"/>
+            <a:rPr lang="en-US" sz="600" kern="1200" dirty="0">
+              <a:hlinkClick xmlns:r="http://schemas.openxmlformats.org/officeDocument/2006/relationships" r:id="rId8"/>
+            </a:rPr>
             <a:t>“However, </a:t>
           </a:r>
           <a:r>
-            <a:rPr lang="en-US" sz="600" b="1" kern="1200" dirty="0"/>
+            <a:rPr lang="en-US" sz="600" b="1" kern="1200" dirty="0">
+              <a:hlinkClick xmlns:r="http://schemas.openxmlformats.org/officeDocument/2006/relationships" r:id="rId8"/>
+            </a:rPr>
             <a:t>apart from the justification of the ungodly</a:t>
           </a:r>
           <a:r>
-            <a:rPr lang="en-US" sz="600" kern="1200" dirty="0"/>
+            <a:rPr lang="en-US" sz="600" kern="1200" dirty="0">
+              <a:hlinkClick xmlns:r="http://schemas.openxmlformats.org/officeDocument/2006/relationships" r:id="rId8"/>
+            </a:rPr>
             <a:t>, even the most majestic facets become condemning law for me as a sinner”(67, par. 2)</a:t>
           </a:r>
           <a:br>
@@ -10734,17 +10883,24 @@
             <a:buNone/>
           </a:pPr>
           <a:r>
-            <a:rPr lang="en-US" sz="800" i="0" kern="1200" dirty="0"/>
+            <a:rPr lang="en-US" sz="800" i="0" kern="1200" dirty="0">
+              <a:hlinkClick xmlns:r="http://schemas.openxmlformats.org/officeDocument/2006/relationships" r:id="rId2"/>
+            </a:rPr>
             <a:t>“ his[Wesley’s] ministers should ‘</a:t>
           </a:r>
           <a:r>
-            <a:rPr lang="en-US" sz="800" b="1" i="0" kern="1200" dirty="0"/>
+            <a:rPr lang="en-US" sz="800" b="1" i="0" kern="1200" dirty="0">
+              <a:hlinkClick xmlns:r="http://schemas.openxmlformats.org/officeDocument/2006/relationships" r:id="rId2"/>
+            </a:rPr>
             <a:t>preach the whole gospel</a:t>
           </a:r>
           <a:r>
-            <a:rPr lang="en-US" sz="800" i="0" kern="1200" dirty="0"/>
+            <a:rPr lang="en-US" sz="800" i="0" kern="1200" dirty="0">
+              <a:hlinkClick xmlns:r="http://schemas.openxmlformats.org/officeDocument/2006/relationships" r:id="rId2"/>
+            </a:rPr>
             <a:t>, even justification and sanctification, preparatory to glory,’”</a:t>
           </a:r>
+          <a:endParaRPr lang="en-US" sz="800" i="0" kern="1200" dirty="0"/>
         </a:p>
         <a:p>
           <a:pPr marL="0" lvl="0" indent="0" algn="l" defTabSz="355600">
@@ -10838,10 +10994,18 @@
           </a:pPr>
           <a:r>
             <a:rPr lang="en-US" sz="800" kern="1200" dirty="0"/>
-            <a:t>The gospel announces deliverance from two problems: “</a:t>
+            <a:t>The gospel announces deliverance from two problems: </a:t>
           </a:r>
           <a:r>
-            <a:rPr lang="en-US" sz="800" b="1" kern="1200" dirty="0"/>
+            <a:rPr lang="en-US" sz="800" kern="1200" dirty="0">
+              <a:hlinkClick xmlns:r="http://schemas.openxmlformats.org/officeDocument/2006/relationships" r:id="rId3"/>
+            </a:rPr>
+            <a:t>“</a:t>
+          </a:r>
+          <a:r>
+            <a:rPr lang="en-US" sz="800" b="1" kern="1200" dirty="0">
+              <a:hlinkClick xmlns:r="http://schemas.openxmlformats.org/officeDocument/2006/relationships" r:id="rId3"/>
+            </a:rPr>
             <a:t>alienation from the life of God</a:t>
           </a:r>
           <a:r>
@@ -10872,32 +11036,61 @@
           </a:pPr>
           <a:r>
             <a:rPr lang="en-US" sz="800" kern="1200" dirty="0"/>
-            <a:t>The solution is justification: “</a:t>
+            <a:t>The solution is justification: </a:t>
           </a:r>
           <a:r>
-            <a:rPr lang="en-US" sz="800" b="1" kern="1200" dirty="0"/>
+            <a:rPr lang="en-US" sz="800" kern="1200" dirty="0">
+              <a:hlinkClick xmlns:r="http://schemas.openxmlformats.org/officeDocument/2006/relationships" r:id="rId4"/>
+            </a:rPr>
+            <a:t>“</a:t>
+          </a:r>
+          <a:r>
+            <a:rPr lang="en-US" sz="800" b="1" kern="1200" dirty="0">
+              <a:hlinkClick xmlns:r="http://schemas.openxmlformats.org/officeDocument/2006/relationships" r:id="rId4"/>
+            </a:rPr>
             <a:t>saved from the guilt of sin</a:t>
           </a:r>
           <a:r>
-            <a:rPr lang="en-US" sz="800" kern="1200" dirty="0"/>
+            <a:rPr lang="en-US" sz="800" kern="1200" dirty="0">
+              <a:hlinkClick xmlns:r="http://schemas.openxmlformats.org/officeDocument/2006/relationships" r:id="rId4"/>
+            </a:rPr>
             <a:t> and restored to the </a:t>
           </a:r>
           <a:r>
-            <a:rPr lang="en-US" sz="800" kern="1200" dirty="0" err="1"/>
+            <a:rPr lang="en-US" sz="800" kern="1200" dirty="0" err="1">
+              <a:hlinkClick xmlns:r="http://schemas.openxmlformats.org/officeDocument/2006/relationships" r:id="rId4"/>
+            </a:rPr>
             <a:t>favour</a:t>
           </a:r>
           <a:r>
-            <a:rPr lang="en-US" sz="800" kern="1200" dirty="0"/>
-            <a:t> of God” and sanctification: “</a:t>
+            <a:rPr lang="en-US" sz="800" kern="1200" dirty="0">
+              <a:hlinkClick xmlns:r="http://schemas.openxmlformats.org/officeDocument/2006/relationships" r:id="rId4"/>
+            </a:rPr>
+            <a:t> of God” </a:t>
           </a:r>
           <a:r>
-            <a:rPr lang="en-US" sz="800" b="1" kern="1200" dirty="0"/>
+            <a:rPr lang="en-US" sz="800" kern="1200" dirty="0"/>
+            <a:t>and sanctification: </a:t>
+          </a:r>
+          <a:r>
+            <a:rPr lang="en-US" sz="800" kern="1200" dirty="0">
+              <a:hlinkClick xmlns:r="http://schemas.openxmlformats.org/officeDocument/2006/relationships" r:id="rId5"/>
+            </a:rPr>
+            <a:t>“</a:t>
+          </a:r>
+          <a:r>
+            <a:rPr lang="en-US" sz="800" b="1" kern="1200" dirty="0">
+              <a:hlinkClick xmlns:r="http://schemas.openxmlformats.org/officeDocument/2006/relationships" r:id="rId5"/>
+            </a:rPr>
             <a:t>saved from the power and root </a:t>
           </a:r>
           <a:r>
-            <a:rPr lang="en-US" sz="800" kern="1200" dirty="0"/>
+            <a:rPr lang="en-US" sz="800" kern="1200" dirty="0">
+              <a:hlinkClick xmlns:r="http://schemas.openxmlformats.org/officeDocument/2006/relationships" r:id="rId5"/>
+            </a:rPr>
             <a:t>of sin, and restored to the image of God”.</a:t>
           </a:r>
+          <a:endParaRPr lang="en-US" sz="800" kern="1200" dirty="0"/>
         </a:p>
       </dsp:txBody>
       <dsp:txXfrm>
@@ -10973,16 +11166,27 @@
           </a:pPr>
           <a:r>
             <a:rPr lang="en-US" sz="800" kern="1200" dirty="0"/>
-            <a:t> “Salvation involves the work both of the Son and Holy Spirit, the Son in ‘giving himself to be ‘</a:t>
+            <a:t> </a:t>
           </a:r>
           <a:r>
-            <a:rPr lang="en-US" sz="800" b="1" kern="1200" dirty="0"/>
+            <a:rPr lang="en-US" sz="800" kern="1200" dirty="0">
+              <a:hlinkClick xmlns:r="http://schemas.openxmlformats.org/officeDocument/2006/relationships" r:id="rId6"/>
+            </a:rPr>
+            <a:t>“Salvation involves the work both of the Son and Holy Spirit, the Son in ‘giving himself to be ‘</a:t>
+          </a:r>
+          <a:r>
+            <a:rPr lang="en-US" sz="800" b="1" kern="1200" dirty="0">
+              <a:hlinkClick xmlns:r="http://schemas.openxmlformats.org/officeDocument/2006/relationships" r:id="rId6"/>
+            </a:rPr>
             <a:t>a propitiation for the sins of the world</a:t>
           </a:r>
           <a:r>
-            <a:rPr lang="en-US" sz="800" kern="1200" dirty="0"/>
+            <a:rPr lang="en-US" sz="800" kern="1200" dirty="0">
+              <a:hlinkClick xmlns:r="http://schemas.openxmlformats.org/officeDocument/2006/relationships" r:id="rId6"/>
+            </a:rPr>
             <a:t>,’ ‘ the Holy Spirit in ‘renewing men in that image of God wherein they were created”</a:t>
           </a:r>
+          <a:endParaRPr lang="en-US" sz="800" kern="1200" dirty="0"/>
         </a:p>
       </dsp:txBody>
       <dsp:txXfrm>
@@ -11057,15 +11261,21 @@
             <a:buNone/>
           </a:pPr>
           <a:r>
-            <a:rPr lang="en-US" sz="800" kern="1200" dirty="0"/>
+            <a:rPr lang="en-US" sz="800" kern="1200" dirty="0">
+              <a:hlinkClick xmlns:r="http://schemas.openxmlformats.org/officeDocument/2006/relationships" r:id="rId7"/>
+            </a:rPr>
             <a:t>“John Wesley’s </a:t>
           </a:r>
           <a:r>
-            <a:rPr lang="en-US" sz="800" b="1" kern="1200" dirty="0"/>
+            <a:rPr lang="en-US" sz="800" b="1" kern="1200" dirty="0">
+              <a:hlinkClick xmlns:r="http://schemas.openxmlformats.org/officeDocument/2006/relationships" r:id="rId7"/>
+            </a:rPr>
             <a:t>spiritual biography constitutes </a:t>
           </a:r>
           <a:r>
-            <a:rPr lang="en-US" sz="800" kern="1200" dirty="0"/>
+            <a:rPr lang="en-US" sz="800" kern="1200" dirty="0">
+              <a:hlinkClick xmlns:r="http://schemas.openxmlformats.org/officeDocument/2006/relationships" r:id="rId7"/>
+            </a:rPr>
             <a:t>one important context for the emergence of his understanding of the gospel.”</a:t>
           </a:r>
           <a:br>
@@ -29672,7 +29882,7 @@
           <p:nvPr>
             <p:extLst>
               <p:ext uri="{D42A27DB-BD31-4B8C-83A1-F6EECF244321}">
-                <p14:modId xmlns:p14="http://schemas.microsoft.com/office/powerpoint/2010/main" val="796254607"/>
+                <p14:modId xmlns:p14="http://schemas.microsoft.com/office/powerpoint/2010/main" val="4059572581"/>
               </p:ext>
             </p:extLst>
           </p:nvPr>
@@ -29875,7 +30085,7 @@
           <p:nvPr>
             <p:extLst>
               <p:ext uri="{D42A27DB-BD31-4B8C-83A1-F6EECF244321}">
-                <p14:modId xmlns:p14="http://schemas.microsoft.com/office/powerpoint/2010/main" val="3198722726"/>
+                <p14:modId xmlns:p14="http://schemas.microsoft.com/office/powerpoint/2010/main" val="3570071452"/>
               </p:ext>
             </p:extLst>
           </p:nvPr>
@@ -31060,6 +31270,14 @@
 </file>
 
 <file path=customXml/item1.xml><?xml version="1.0" encoding="utf-8"?>
+<p:properties xmlns:p="http://schemas.microsoft.com/office/2006/metadata/properties" xmlns:xsi="http://www.w3.org/2001/XMLSchema-instance" xmlns:pc="http://schemas.microsoft.com/office/infopath/2007/PartnerControls">
+  <documentManagement>
+    <_activity xmlns="cc328e4a-acc5-4db9-8edf-03a7e14d7082" xsi:nil="true"/>
+  </documentManagement>
+</p:properties>
+</file>
+
+<file path=customXml/item2.xml><?xml version="1.0" encoding="utf-8"?>
 <ct:contentTypeSchema xmlns:ct="http://schemas.microsoft.com/office/2006/metadata/contentType" xmlns:ma="http://schemas.microsoft.com/office/2006/metadata/properties/metaAttributes" ct:_="" ma:_="" ma:contentTypeName="Document" ma:contentTypeID="0x0101008E645426CC3C3348B900E57479C898EF" ma:contentTypeVersion="15" ma:contentTypeDescription="Create a new document." ma:contentTypeScope="" ma:versionID="4bc64779f88d1d78707623c1e29ebd00">
   <xsd:schema xmlns:xsd="http://www.w3.org/2001/XMLSchema" xmlns:xs="http://www.w3.org/2001/XMLSchema" xmlns:p="http://schemas.microsoft.com/office/2006/metadata/properties" xmlns:ns3="cc328e4a-acc5-4db9-8edf-03a7e14d7082" xmlns:ns4="5a361508-a8bd-49ac-aae1-a5acde08ec86" targetNamespace="http://schemas.microsoft.com/office/2006/metadata/properties" ma:root="true" ma:fieldsID="3d4d223e92318e0d0dc86e292859e212" ns3:_="" ns4:_="">
     <xsd:import namespace="cc328e4a-acc5-4db9-8edf-03a7e14d7082"/>
@@ -31294,14 +31512,6 @@
 </ct:contentTypeSchema>
 </file>
 
-<file path=customXml/item2.xml><?xml version="1.0" encoding="utf-8"?>
-<p:properties xmlns:p="http://schemas.microsoft.com/office/2006/metadata/properties" xmlns:xsi="http://www.w3.org/2001/XMLSchema-instance" xmlns:pc="http://schemas.microsoft.com/office/infopath/2007/PartnerControls">
-  <documentManagement>
-    <_activity xmlns="cc328e4a-acc5-4db9-8edf-03a7e14d7082" xsi:nil="true"/>
-  </documentManagement>
-</p:properties>
-</file>
-
 <file path=customXml/item3.xml><?xml version="1.0" encoding="utf-8"?>
 <?mso-contentType ?>
 <FormTemplates xmlns="http://schemas.microsoft.com/sharepoint/v3/contenttype/forms">
@@ -31312,6 +31522,18 @@
 </file>
 
 <file path=customXml/itemProps1.xml><?xml version="1.0" encoding="utf-8"?>
+<ds:datastoreItem xmlns:ds="http://schemas.openxmlformats.org/officeDocument/2006/customXml" ds:itemID="{CF4B5514-C2B0-415F-9108-B3264F87DDF2}">
+  <ds:schemaRefs>
+    <ds:schemaRef ds:uri="http://schemas.microsoft.com/office/2006/metadata/properties"/>
+    <ds:schemaRef ds:uri="http://www.w3.org/2000/xmlns/"/>
+    <ds:schemaRef ds:uri="cc328e4a-acc5-4db9-8edf-03a7e14d7082"/>
+    <ds:schemaRef ds:uri="http://www.w3.org/2001/XMLSchema-instance"/>
+    <ds:schemaRef ds:uri="http://schemas.microsoft.com/office/infopath/2007/PartnerControls"/>
+  </ds:schemaRefs>
+</ds:datastoreItem>
+</file>
+
+<file path=customXml/itemProps2.xml><?xml version="1.0" encoding="utf-8"?>
 <ds:datastoreItem xmlns:ds="http://schemas.openxmlformats.org/officeDocument/2006/customXml" ds:itemID="{568CD85B-F839-4F4F-A8A4-47102501B797}">
   <ds:schemaRefs>
     <ds:schemaRef ds:uri="http://schemas.microsoft.com/office/2006/metadata/contentType"/>
@@ -31331,18 +31553,6 @@
 </ds:datastoreItem>
 </file>
 
-<file path=customXml/itemProps2.xml><?xml version="1.0" encoding="utf-8"?>
-<ds:datastoreItem xmlns:ds="http://schemas.openxmlformats.org/officeDocument/2006/customXml" ds:itemID="{CF4B5514-C2B0-415F-9108-B3264F87DDF2}">
-  <ds:schemaRefs>
-    <ds:schemaRef ds:uri="http://schemas.microsoft.com/office/2006/metadata/properties"/>
-    <ds:schemaRef ds:uri="http://www.w3.org/2000/xmlns/"/>
-    <ds:schemaRef ds:uri="cc328e4a-acc5-4db9-8edf-03a7e14d7082"/>
-    <ds:schemaRef ds:uri="http://www.w3.org/2001/XMLSchema-instance"/>
-    <ds:schemaRef ds:uri="http://schemas.microsoft.com/office/infopath/2007/PartnerControls"/>
-  </ds:schemaRefs>
-</ds:datastoreItem>
-</file>
-
 <file path=customXml/itemProps3.xml><?xml version="1.0" encoding="utf-8"?>
 <ds:datastoreItem xmlns:ds="http://schemas.openxmlformats.org/officeDocument/2006/customXml" ds:itemID="{8044CA59-19DA-4472-821C-352737C499D2}">
   <ds:schemaRefs>

</xml_diff>

<commit_message>
Align basic input and expected fixtures
</commit_message>
<xml_diff>
--- a/tests/examples/case_01_basic/expected.pptx
+++ b/tests/examples/case_01_basic/expected.pptx
@@ -4031,15 +4031,21 @@
         <a:p>
           <a:pPr algn="l"/>
           <a:r>
-            <a:rPr lang="en-US" dirty="0"/>
+            <a:rPr lang="en-US" dirty="0">
+              <a:hlinkClick xmlns:r="http://schemas.openxmlformats.org/officeDocument/2006/relationships" r:id="rId2"/>
+            </a:rPr>
             <a:t>“</a:t>
           </a:r>
           <a:r>
-            <a:rPr lang="en-US" b="1" dirty="0"/>
+            <a:rPr lang="en-US" b="1" dirty="0">
+              <a:hlinkClick xmlns:r="http://schemas.openxmlformats.org/officeDocument/2006/relationships" r:id="rId2"/>
+            </a:rPr>
             <a:t>The solution Jesus offers to the Galileans and Judeans of his day was the kingdom</a:t>
           </a:r>
           <a:r>
-            <a:rPr lang="en-US" dirty="0"/>
+            <a:rPr lang="en-US" dirty="0">
+              <a:hlinkClick xmlns:r="http://schemas.openxmlformats.org/officeDocument/2006/relationships" r:id="rId2"/>
+            </a:rPr>
             <a:t> … More than one hundred times this word is found in the Synoptic Gospels, even if it is rendered into ‘life’ and ‘eternal life’ in the Fourth Gospel.”(28)</a:t>
           </a:r>
           <a:endParaRPr lang="en-US" i="1" dirty="0"/>
@@ -5290,15 +5296,21 @@
         <a:p>
           <a:pPr algn="l"/>
           <a:r>
-            <a:rPr lang="en-US" dirty="0"/>
+            <a:rPr lang="en-US" dirty="0">
+              <a:hlinkClick xmlns:r="http://schemas.openxmlformats.org/officeDocument/2006/relationships" r:id="rId9"/>
+            </a:rPr>
             <a:t>“</a:t>
           </a:r>
           <a:r>
-            <a:rPr lang="en-US" b="1" dirty="0"/>
+            <a:rPr lang="en-US" b="1" dirty="0">
+              <a:hlinkClick xmlns:r="http://schemas.openxmlformats.org/officeDocument/2006/relationships" r:id="rId9"/>
+            </a:rPr>
             <a:t>Through all these events </a:t>
           </a:r>
           <a:r>
-            <a:rPr lang="en-US" dirty="0"/>
+            <a:rPr lang="en-US" dirty="0">
+              <a:hlinkClick xmlns:r="http://schemas.openxmlformats.org/officeDocument/2006/relationships" r:id="rId9"/>
+            </a:rPr>
             <a:t>in Christ’s life, those who are united to him are forgiven, justified, sanctified and glorified. Consequently, the gospel cannot be reduced to justification.”(67f, par.1 )</a:t>
           </a:r>
           <a:br>
@@ -5344,30 +5356,42 @@
         <a:p>
           <a:pPr algn="l"/>
           <a:r>
-            <a:rPr lang="en-US" dirty="0"/>
+            <a:rPr lang="en-US" dirty="0">
+              <a:hlinkClick xmlns:r="http://schemas.openxmlformats.org/officeDocument/2006/relationships" r:id="rId10"/>
+            </a:rPr>
             <a:t>“Is it the Old Testament, first-century Judea, the Roman imperial cult, human sin and fallenness, the Reformation, the surrounding culture, or experience of the oppression? Again, I </a:t>
           </a:r>
           <a:r>
-            <a:rPr lang="en-US" b="1" dirty="0"/>
+            <a:rPr lang="en-US" b="1" dirty="0">
+              <a:hlinkClick xmlns:r="http://schemas.openxmlformats.org/officeDocument/2006/relationships" r:id="rId10"/>
+            </a:rPr>
             <a:t>find myself wanting to answer</a:t>
           </a:r>
           <a:r>
-            <a:rPr lang="en-US" dirty="0"/>
+            <a:rPr lang="en-US" dirty="0">
+              <a:hlinkClick xmlns:r="http://schemas.openxmlformats.org/officeDocument/2006/relationships" r:id="rId10"/>
+            </a:rPr>
             <a:t>: ‘yes.’ Like all Christian doctrines, justification has s reception history. However, it is a context, not a norm.”(68, par. 3)</a:t>
           </a:r>
           <a:br>
             <a:rPr lang="en-US" dirty="0"/>
           </a:br>
           <a:r>
-            <a:rPr lang="en-US" dirty="0"/>
+            <a:rPr lang="en-US" dirty="0">
+              <a:hlinkClick xmlns:r="http://schemas.openxmlformats.org/officeDocument/2006/relationships" r:id="rId11"/>
+            </a:rPr>
             <a:t>“The primary context, then, is the history of the </a:t>
           </a:r>
           <a:r>
-            <a:rPr lang="en-US" b="1" dirty="0"/>
+            <a:rPr lang="en-US" b="1" dirty="0">
+              <a:hlinkClick xmlns:r="http://schemas.openxmlformats.org/officeDocument/2006/relationships" r:id="rId11"/>
+            </a:rPr>
             <a:t>covenant of grace</a:t>
           </a:r>
           <a:r>
-            <a:rPr lang="en-US" dirty="0"/>
+            <a:rPr lang="en-US" dirty="0">
+              <a:hlinkClick xmlns:r="http://schemas.openxmlformats.org/officeDocument/2006/relationships" r:id="rId11"/>
+            </a:rPr>
             <a:t>”(71, par.4)</a:t>
           </a:r>
           <a:br>
@@ -5412,23 +5436,33 @@
         <a:lstStyle/>
         <a:p>
           <a:r>
-            <a:rPr lang="en-US" dirty="0"/>
+            <a:rPr lang="en-US" dirty="0">
+              <a:hlinkClick xmlns:r="http://schemas.openxmlformats.org/officeDocument/2006/relationships" r:id="rId12"/>
+            </a:rPr>
             <a:t>“The </a:t>
           </a:r>
           <a:r>
-            <a:rPr lang="en-US" b="1" dirty="0"/>
+            <a:rPr lang="en-US" b="1" dirty="0">
+              <a:hlinkClick xmlns:r="http://schemas.openxmlformats.org/officeDocument/2006/relationships" r:id="rId12"/>
+            </a:rPr>
             <a:t>gospel is an announce</a:t>
           </a:r>
           <a:r>
-            <a:rPr lang="en-US" b="0" dirty="0"/>
+            <a:rPr lang="en-US" b="0" dirty="0">
+              <a:hlinkClick xmlns:r="http://schemas.openxmlformats.org/officeDocument/2006/relationships" r:id="rId12"/>
+            </a:rPr>
             <a:t>ment</a:t>
           </a:r>
           <a:r>
-            <a:rPr lang="en-US" b="1" dirty="0"/>
+            <a:rPr lang="en-US" b="1" dirty="0">
+              <a:hlinkClick xmlns:r="http://schemas.openxmlformats.org/officeDocument/2006/relationships" r:id="rId12"/>
+            </a:rPr>
             <a:t> </a:t>
           </a:r>
           <a:r>
-            <a:rPr lang="en-US" dirty="0"/>
+            <a:rPr lang="en-US" dirty="0">
+              <a:hlinkClick xmlns:r="http://schemas.openxmlformats.org/officeDocument/2006/relationships" r:id="rId12"/>
+            </a:rPr>
             <a:t>that God has fulfilled his pledge”(74, par 1)</a:t>
           </a:r>
           <a:br>
@@ -6128,7 +6162,9 @@
             <a:t>” and “</a:t>
           </a:r>
           <a:r>
-            <a:rPr lang="en-US" b="1" dirty="0"/>
+            <a:rPr lang="en-US" b="1" dirty="0">
+              <a:hlinkClick xmlns:r="http://schemas.openxmlformats.org/officeDocument/2006/relationships" r:id="rId4"/>
+            </a:rPr>
             <a:t>deformation of their vary nature</a:t>
           </a:r>
           <a:r>
@@ -6144,31 +6180,31 @@
           </a:r>
           <a:r>
             <a:rPr lang="en-US" dirty="0">
-              <a:hlinkClick xmlns:r="http://schemas.openxmlformats.org/officeDocument/2006/relationships" r:id="rId4"/>
+              <a:hlinkClick xmlns:r="http://schemas.openxmlformats.org/officeDocument/2006/relationships" r:id="rId5"/>
             </a:rPr>
             <a:t>“</a:t>
           </a:r>
           <a:r>
             <a:rPr lang="en-US" b="1" dirty="0">
-              <a:hlinkClick xmlns:r="http://schemas.openxmlformats.org/officeDocument/2006/relationships" r:id="rId4"/>
+              <a:hlinkClick xmlns:r="http://schemas.openxmlformats.org/officeDocument/2006/relationships" r:id="rId5"/>
             </a:rPr>
             <a:t>saved from the guilt of sin</a:t>
           </a:r>
           <a:r>
             <a:rPr lang="en-US" dirty="0">
-              <a:hlinkClick xmlns:r="http://schemas.openxmlformats.org/officeDocument/2006/relationships" r:id="rId4"/>
+              <a:hlinkClick xmlns:r="http://schemas.openxmlformats.org/officeDocument/2006/relationships" r:id="rId5"/>
             </a:rPr>
             <a:t> and restored to the </a:t>
           </a:r>
           <a:r>
             <a:rPr lang="en-US" dirty="0" err="1">
-              <a:hlinkClick xmlns:r="http://schemas.openxmlformats.org/officeDocument/2006/relationships" r:id="rId4"/>
+              <a:hlinkClick xmlns:r="http://schemas.openxmlformats.org/officeDocument/2006/relationships" r:id="rId5"/>
             </a:rPr>
             <a:t>favour</a:t>
           </a:r>
           <a:r>
             <a:rPr lang="en-US" dirty="0">
-              <a:hlinkClick xmlns:r="http://schemas.openxmlformats.org/officeDocument/2006/relationships" r:id="rId4"/>
+              <a:hlinkClick xmlns:r="http://schemas.openxmlformats.org/officeDocument/2006/relationships" r:id="rId5"/>
             </a:rPr>
             <a:t> of God” </a:t>
           </a:r>
@@ -6178,19 +6214,19 @@
           </a:r>
           <a:r>
             <a:rPr lang="en-US" dirty="0">
-              <a:hlinkClick xmlns:r="http://schemas.openxmlformats.org/officeDocument/2006/relationships" r:id="rId5"/>
+              <a:hlinkClick xmlns:r="http://schemas.openxmlformats.org/officeDocument/2006/relationships" r:id="rId6"/>
             </a:rPr>
             <a:t>“</a:t>
           </a:r>
           <a:r>
             <a:rPr lang="en-US" b="1" dirty="0">
-              <a:hlinkClick xmlns:r="http://schemas.openxmlformats.org/officeDocument/2006/relationships" r:id="rId5"/>
+              <a:hlinkClick xmlns:r="http://schemas.openxmlformats.org/officeDocument/2006/relationships" r:id="rId6"/>
             </a:rPr>
             <a:t>saved from the power and root </a:t>
           </a:r>
           <a:r>
             <a:rPr lang="en-US" dirty="0">
-              <a:hlinkClick xmlns:r="http://schemas.openxmlformats.org/officeDocument/2006/relationships" r:id="rId5"/>
+              <a:hlinkClick xmlns:r="http://schemas.openxmlformats.org/officeDocument/2006/relationships" r:id="rId6"/>
             </a:rPr>
             <a:t>of sin, and restored to the image of God”.</a:t>
           </a:r>
@@ -6235,19 +6271,19 @@
           </a:r>
           <a:r>
             <a:rPr lang="en-US" dirty="0">
-              <a:hlinkClick xmlns:r="http://schemas.openxmlformats.org/officeDocument/2006/relationships" r:id="rId6"/>
+              <a:hlinkClick xmlns:r="http://schemas.openxmlformats.org/officeDocument/2006/relationships" r:id="rId7"/>
             </a:rPr>
             <a:t>“Salvation involves the work both of the Son and Holy Spirit, the Son in ‘giving himself to be ‘</a:t>
           </a:r>
           <a:r>
             <a:rPr lang="en-US" b="1" dirty="0">
-              <a:hlinkClick xmlns:r="http://schemas.openxmlformats.org/officeDocument/2006/relationships" r:id="rId6"/>
+              <a:hlinkClick xmlns:r="http://schemas.openxmlformats.org/officeDocument/2006/relationships" r:id="rId7"/>
             </a:rPr>
             <a:t>a propitiation for the sins of the world</a:t>
           </a:r>
           <a:r>
             <a:rPr lang="en-US" dirty="0">
-              <a:hlinkClick xmlns:r="http://schemas.openxmlformats.org/officeDocument/2006/relationships" r:id="rId6"/>
+              <a:hlinkClick xmlns:r="http://schemas.openxmlformats.org/officeDocument/2006/relationships" r:id="rId7"/>
             </a:rPr>
             <a:t>,’ ‘ the Holy Spirit in ‘renewing men in that image of God wherein they were created”</a:t>
           </a:r>
@@ -6288,19 +6324,19 @@
           <a:pPr algn="l"/>
           <a:r>
             <a:rPr lang="en-US" dirty="0">
-              <a:hlinkClick xmlns:r="http://schemas.openxmlformats.org/officeDocument/2006/relationships" r:id="rId7"/>
+              <a:hlinkClick xmlns:r="http://schemas.openxmlformats.org/officeDocument/2006/relationships" r:id="rId8"/>
             </a:rPr>
             <a:t>“John Wesley’s </a:t>
           </a:r>
           <a:r>
             <a:rPr lang="en-US" b="1" dirty="0">
-              <a:hlinkClick xmlns:r="http://schemas.openxmlformats.org/officeDocument/2006/relationships" r:id="rId7"/>
+              <a:hlinkClick xmlns:r="http://schemas.openxmlformats.org/officeDocument/2006/relationships" r:id="rId8"/>
             </a:rPr>
             <a:t>spiritual biography constitutes </a:t>
           </a:r>
           <a:r>
             <a:rPr lang="en-US" dirty="0">
-              <a:hlinkClick xmlns:r="http://schemas.openxmlformats.org/officeDocument/2006/relationships" r:id="rId7"/>
+              <a:hlinkClick xmlns:r="http://schemas.openxmlformats.org/officeDocument/2006/relationships" r:id="rId8"/>
             </a:rPr>
             <a:t>one important context for the emergence of his understanding of the gospel.”</a:t>
           </a:r>
@@ -8246,15 +8282,21 @@
             <a:buNone/>
           </a:pPr>
           <a:r>
-            <a:rPr lang="en-US" sz="500" kern="1200" dirty="0"/>
+            <a:rPr lang="en-US" sz="500" kern="1200" dirty="0">
+              <a:hlinkClick xmlns:r="http://schemas.openxmlformats.org/officeDocument/2006/relationships" r:id="rId2"/>
+            </a:rPr>
             <a:t>“</a:t>
           </a:r>
           <a:r>
-            <a:rPr lang="en-US" sz="500" b="1" kern="1200" dirty="0"/>
+            <a:rPr lang="en-US" sz="500" b="1" kern="1200" dirty="0">
+              <a:hlinkClick xmlns:r="http://schemas.openxmlformats.org/officeDocument/2006/relationships" r:id="rId2"/>
+            </a:rPr>
             <a:t>The solution Jesus offers to the Galileans and Judeans of his day was the kingdom</a:t>
           </a:r>
           <a:r>
-            <a:rPr lang="en-US" sz="500" kern="1200" dirty="0"/>
+            <a:rPr lang="en-US" sz="500" kern="1200" dirty="0">
+              <a:hlinkClick xmlns:r="http://schemas.openxmlformats.org/officeDocument/2006/relationships" r:id="rId2"/>
+            </a:rPr>
             <a:t> … More than one hundred times this word is found in the Synoptic Gospels, even if it is rendered into ‘life’ and ‘eternal life’ in the Fourth Gospel.”(28)</a:t>
           </a:r>
           <a:endParaRPr lang="en-US" sz="500" i="1" kern="1200" dirty="0"/>
@@ -10207,15 +10249,21 @@
             <a:buNone/>
           </a:pPr>
           <a:r>
-            <a:rPr lang="en-US" sz="600" kern="1200" dirty="0"/>
+            <a:rPr lang="en-US" sz="600" kern="1200" dirty="0">
+              <a:hlinkClick xmlns:r="http://schemas.openxmlformats.org/officeDocument/2006/relationships" r:id="rId9"/>
+            </a:rPr>
             <a:t>“</a:t>
           </a:r>
           <a:r>
-            <a:rPr lang="en-US" sz="600" b="1" kern="1200" dirty="0"/>
+            <a:rPr lang="en-US" sz="600" b="1" kern="1200" dirty="0">
+              <a:hlinkClick xmlns:r="http://schemas.openxmlformats.org/officeDocument/2006/relationships" r:id="rId9"/>
+            </a:rPr>
             <a:t>Through all these events </a:t>
           </a:r>
           <a:r>
-            <a:rPr lang="en-US" sz="600" kern="1200" dirty="0"/>
+            <a:rPr lang="en-US" sz="600" kern="1200" dirty="0">
+              <a:hlinkClick xmlns:r="http://schemas.openxmlformats.org/officeDocument/2006/relationships" r:id="rId9"/>
+            </a:rPr>
             <a:t>in Christ’s life, those who are united to him are forgiven, justified, sanctified and glorified. Consequently, the gospel cannot be reduced to justification.”(67f, par.1 )</a:t>
           </a:r>
           <a:br>
@@ -10300,30 +10348,42 @@
             <a:buNone/>
           </a:pPr>
           <a:r>
-            <a:rPr lang="en-US" sz="600" kern="1200" dirty="0"/>
+            <a:rPr lang="en-US" sz="600" kern="1200" dirty="0">
+              <a:hlinkClick xmlns:r="http://schemas.openxmlformats.org/officeDocument/2006/relationships" r:id="rId10"/>
+            </a:rPr>
             <a:t>“Is it the Old Testament, first-century Judea, the Roman imperial cult, human sin and fallenness, the Reformation, the surrounding culture, or experience of the oppression? Again, I </a:t>
           </a:r>
           <a:r>
-            <a:rPr lang="en-US" sz="600" b="1" kern="1200" dirty="0"/>
+            <a:rPr lang="en-US" sz="600" b="1" kern="1200" dirty="0">
+              <a:hlinkClick xmlns:r="http://schemas.openxmlformats.org/officeDocument/2006/relationships" r:id="rId10"/>
+            </a:rPr>
             <a:t>find myself wanting to answer</a:t>
           </a:r>
           <a:r>
-            <a:rPr lang="en-US" sz="600" kern="1200" dirty="0"/>
+            <a:rPr lang="en-US" sz="600" kern="1200" dirty="0">
+              <a:hlinkClick xmlns:r="http://schemas.openxmlformats.org/officeDocument/2006/relationships" r:id="rId10"/>
+            </a:rPr>
             <a:t>: ‘yes.’ Like all Christian doctrines, justification has s reception history. However, it is a context, not a norm.”(68, par. 3)</a:t>
           </a:r>
           <a:br>
             <a:rPr lang="en-US" sz="600" kern="1200" dirty="0"/>
           </a:br>
           <a:r>
-            <a:rPr lang="en-US" sz="600" kern="1200" dirty="0"/>
+            <a:rPr lang="en-US" sz="600" kern="1200" dirty="0">
+              <a:hlinkClick xmlns:r="http://schemas.openxmlformats.org/officeDocument/2006/relationships" r:id="rId11"/>
+            </a:rPr>
             <a:t>“The primary context, then, is the history of the </a:t>
           </a:r>
           <a:r>
-            <a:rPr lang="en-US" sz="600" b="1" kern="1200" dirty="0"/>
+            <a:rPr lang="en-US" sz="600" b="1" kern="1200" dirty="0">
+              <a:hlinkClick xmlns:r="http://schemas.openxmlformats.org/officeDocument/2006/relationships" r:id="rId11"/>
+            </a:rPr>
             <a:t>covenant of grace</a:t>
           </a:r>
           <a:r>
-            <a:rPr lang="en-US" sz="600" kern="1200" dirty="0"/>
+            <a:rPr lang="en-US" sz="600" kern="1200" dirty="0">
+              <a:hlinkClick xmlns:r="http://schemas.openxmlformats.org/officeDocument/2006/relationships" r:id="rId11"/>
+            </a:rPr>
             <a:t>”(71, par.4)</a:t>
           </a:r>
           <a:br>
@@ -10408,23 +10468,33 @@
             <a:buNone/>
           </a:pPr>
           <a:r>
-            <a:rPr lang="en-US" sz="600" kern="1200" dirty="0"/>
+            <a:rPr lang="en-US" sz="600" kern="1200" dirty="0">
+              <a:hlinkClick xmlns:r="http://schemas.openxmlformats.org/officeDocument/2006/relationships" r:id="rId12"/>
+            </a:rPr>
             <a:t>“The </a:t>
           </a:r>
           <a:r>
-            <a:rPr lang="en-US" sz="600" b="1" kern="1200" dirty="0"/>
+            <a:rPr lang="en-US" sz="600" b="1" kern="1200" dirty="0">
+              <a:hlinkClick xmlns:r="http://schemas.openxmlformats.org/officeDocument/2006/relationships" r:id="rId12"/>
+            </a:rPr>
             <a:t>gospel is an announce</a:t>
           </a:r>
           <a:r>
-            <a:rPr lang="en-US" sz="600" b="0" kern="1200" dirty="0"/>
+            <a:rPr lang="en-US" sz="600" b="0" kern="1200" dirty="0">
+              <a:hlinkClick xmlns:r="http://schemas.openxmlformats.org/officeDocument/2006/relationships" r:id="rId12"/>
+            </a:rPr>
             <a:t>ment</a:t>
           </a:r>
           <a:r>
-            <a:rPr lang="en-US" sz="600" b="1" kern="1200" dirty="0"/>
+            <a:rPr lang="en-US" sz="600" b="1" kern="1200" dirty="0">
+              <a:hlinkClick xmlns:r="http://schemas.openxmlformats.org/officeDocument/2006/relationships" r:id="rId12"/>
+            </a:rPr>
             <a:t> </a:t>
           </a:r>
           <a:r>
-            <a:rPr lang="en-US" sz="600" kern="1200" dirty="0"/>
+            <a:rPr lang="en-US" sz="600" kern="1200" dirty="0">
+              <a:hlinkClick xmlns:r="http://schemas.openxmlformats.org/officeDocument/2006/relationships" r:id="rId12"/>
+            </a:rPr>
             <a:t>that God has fulfilled his pledge”(74, par 1)</a:t>
           </a:r>
           <a:br>
@@ -11013,7 +11083,9 @@
             <a:t>” and “</a:t>
           </a:r>
           <a:r>
-            <a:rPr lang="en-US" sz="800" b="1" kern="1200" dirty="0"/>
+            <a:rPr lang="en-US" sz="800" b="1" kern="1200" dirty="0">
+              <a:hlinkClick xmlns:r="http://schemas.openxmlformats.org/officeDocument/2006/relationships" r:id="rId4"/>
+            </a:rPr>
             <a:t>deformation of their vary nature</a:t>
           </a:r>
           <a:r>
@@ -11040,31 +11112,31 @@
           </a:r>
           <a:r>
             <a:rPr lang="en-US" sz="800" kern="1200" dirty="0">
-              <a:hlinkClick xmlns:r="http://schemas.openxmlformats.org/officeDocument/2006/relationships" r:id="rId4"/>
+              <a:hlinkClick xmlns:r="http://schemas.openxmlformats.org/officeDocument/2006/relationships" r:id="rId5"/>
             </a:rPr>
             <a:t>“</a:t>
           </a:r>
           <a:r>
             <a:rPr lang="en-US" sz="800" b="1" kern="1200" dirty="0">
-              <a:hlinkClick xmlns:r="http://schemas.openxmlformats.org/officeDocument/2006/relationships" r:id="rId4"/>
+              <a:hlinkClick xmlns:r="http://schemas.openxmlformats.org/officeDocument/2006/relationships" r:id="rId5"/>
             </a:rPr>
             <a:t>saved from the guilt of sin</a:t>
           </a:r>
           <a:r>
             <a:rPr lang="en-US" sz="800" kern="1200" dirty="0">
-              <a:hlinkClick xmlns:r="http://schemas.openxmlformats.org/officeDocument/2006/relationships" r:id="rId4"/>
+              <a:hlinkClick xmlns:r="http://schemas.openxmlformats.org/officeDocument/2006/relationships" r:id="rId5"/>
             </a:rPr>
             <a:t> and restored to the </a:t>
           </a:r>
           <a:r>
             <a:rPr lang="en-US" sz="800" kern="1200" dirty="0" err="1">
-              <a:hlinkClick xmlns:r="http://schemas.openxmlformats.org/officeDocument/2006/relationships" r:id="rId4"/>
+              <a:hlinkClick xmlns:r="http://schemas.openxmlformats.org/officeDocument/2006/relationships" r:id="rId5"/>
             </a:rPr>
             <a:t>favour</a:t>
           </a:r>
           <a:r>
             <a:rPr lang="en-US" sz="800" kern="1200" dirty="0">
-              <a:hlinkClick xmlns:r="http://schemas.openxmlformats.org/officeDocument/2006/relationships" r:id="rId4"/>
+              <a:hlinkClick xmlns:r="http://schemas.openxmlformats.org/officeDocument/2006/relationships" r:id="rId5"/>
             </a:rPr>
             <a:t> of God” </a:t>
           </a:r>
@@ -11074,19 +11146,19 @@
           </a:r>
           <a:r>
             <a:rPr lang="en-US" sz="800" kern="1200" dirty="0">
-              <a:hlinkClick xmlns:r="http://schemas.openxmlformats.org/officeDocument/2006/relationships" r:id="rId5"/>
+              <a:hlinkClick xmlns:r="http://schemas.openxmlformats.org/officeDocument/2006/relationships" r:id="rId6"/>
             </a:rPr>
             <a:t>“</a:t>
           </a:r>
           <a:r>
             <a:rPr lang="en-US" sz="800" b="1" kern="1200" dirty="0">
-              <a:hlinkClick xmlns:r="http://schemas.openxmlformats.org/officeDocument/2006/relationships" r:id="rId5"/>
+              <a:hlinkClick xmlns:r="http://schemas.openxmlformats.org/officeDocument/2006/relationships" r:id="rId6"/>
             </a:rPr>
             <a:t>saved from the power and root </a:t>
           </a:r>
           <a:r>
             <a:rPr lang="en-US" sz="800" kern="1200" dirty="0">
-              <a:hlinkClick xmlns:r="http://schemas.openxmlformats.org/officeDocument/2006/relationships" r:id="rId5"/>
+              <a:hlinkClick xmlns:r="http://schemas.openxmlformats.org/officeDocument/2006/relationships" r:id="rId6"/>
             </a:rPr>
             <a:t>of sin, and restored to the image of God”.</a:t>
           </a:r>
@@ -11170,19 +11242,19 @@
           </a:r>
           <a:r>
             <a:rPr lang="en-US" sz="800" kern="1200" dirty="0">
-              <a:hlinkClick xmlns:r="http://schemas.openxmlformats.org/officeDocument/2006/relationships" r:id="rId6"/>
+              <a:hlinkClick xmlns:r="http://schemas.openxmlformats.org/officeDocument/2006/relationships" r:id="rId7"/>
             </a:rPr>
             <a:t>“Salvation involves the work both of the Son and Holy Spirit, the Son in ‘giving himself to be ‘</a:t>
           </a:r>
           <a:r>
             <a:rPr lang="en-US" sz="800" b="1" kern="1200" dirty="0">
-              <a:hlinkClick xmlns:r="http://schemas.openxmlformats.org/officeDocument/2006/relationships" r:id="rId6"/>
+              <a:hlinkClick xmlns:r="http://schemas.openxmlformats.org/officeDocument/2006/relationships" r:id="rId7"/>
             </a:rPr>
             <a:t>a propitiation for the sins of the world</a:t>
           </a:r>
           <a:r>
             <a:rPr lang="en-US" sz="800" kern="1200" dirty="0">
-              <a:hlinkClick xmlns:r="http://schemas.openxmlformats.org/officeDocument/2006/relationships" r:id="rId6"/>
+              <a:hlinkClick xmlns:r="http://schemas.openxmlformats.org/officeDocument/2006/relationships" r:id="rId7"/>
             </a:rPr>
             <a:t>,’ ‘ the Holy Spirit in ‘renewing men in that image of God wherein they were created”</a:t>
           </a:r>
@@ -11262,19 +11334,19 @@
           </a:pPr>
           <a:r>
             <a:rPr lang="en-US" sz="800" kern="1200" dirty="0">
-              <a:hlinkClick xmlns:r="http://schemas.openxmlformats.org/officeDocument/2006/relationships" r:id="rId7"/>
+              <a:hlinkClick xmlns:r="http://schemas.openxmlformats.org/officeDocument/2006/relationships" r:id="rId8"/>
             </a:rPr>
             <a:t>“John Wesley’s </a:t>
           </a:r>
           <a:r>
             <a:rPr lang="en-US" sz="800" b="1" kern="1200" dirty="0">
-              <a:hlinkClick xmlns:r="http://schemas.openxmlformats.org/officeDocument/2006/relationships" r:id="rId7"/>
+              <a:hlinkClick xmlns:r="http://schemas.openxmlformats.org/officeDocument/2006/relationships" r:id="rId8"/>
             </a:rPr>
             <a:t>spiritual biography constitutes </a:t>
           </a:r>
           <a:r>
             <a:rPr lang="en-US" sz="800" kern="1200" dirty="0">
-              <a:hlinkClick xmlns:r="http://schemas.openxmlformats.org/officeDocument/2006/relationships" r:id="rId7"/>
+              <a:hlinkClick xmlns:r="http://schemas.openxmlformats.org/officeDocument/2006/relationships" r:id="rId8"/>
             </a:rPr>
             <a:t>one important context for the emergence of his understanding of the gospel.”</a:t>
           </a:r>
@@ -29651,7 +29723,7 @@
           <p:nvPr>
             <p:extLst>
               <p:ext uri="{D42A27DB-BD31-4B8C-83A1-F6EECF244321}">
-                <p14:modId xmlns:p14="http://schemas.microsoft.com/office/powerpoint/2010/main" val="3643715462"/>
+                <p14:modId xmlns:p14="http://schemas.microsoft.com/office/powerpoint/2010/main" val="1677600489"/>
               </p:ext>
             </p:extLst>
           </p:nvPr>
@@ -29882,7 +29954,7 @@
           <p:nvPr>
             <p:extLst>
               <p:ext uri="{D42A27DB-BD31-4B8C-83A1-F6EECF244321}">
-                <p14:modId xmlns:p14="http://schemas.microsoft.com/office/powerpoint/2010/main" val="4059572581"/>
+                <p14:modId xmlns:p14="http://schemas.microsoft.com/office/powerpoint/2010/main" val="4042689645"/>
               </p:ext>
             </p:extLst>
           </p:nvPr>
@@ -30085,7 +30157,7 @@
           <p:nvPr>
             <p:extLst>
               <p:ext uri="{D42A27DB-BD31-4B8C-83A1-F6EECF244321}">
-                <p14:modId xmlns:p14="http://schemas.microsoft.com/office/powerpoint/2010/main" val="3570071452"/>
+                <p14:modId xmlns:p14="http://schemas.microsoft.com/office/powerpoint/2010/main" val="2528833317"/>
               </p:ext>
             </p:extLst>
           </p:nvPr>
@@ -31270,14 +31342,6 @@
 </file>
 
 <file path=customXml/item1.xml><?xml version="1.0" encoding="utf-8"?>
-<p:properties xmlns:p="http://schemas.microsoft.com/office/2006/metadata/properties" xmlns:xsi="http://www.w3.org/2001/XMLSchema-instance" xmlns:pc="http://schemas.microsoft.com/office/infopath/2007/PartnerControls">
-  <documentManagement>
-    <_activity xmlns="cc328e4a-acc5-4db9-8edf-03a7e14d7082" xsi:nil="true"/>
-  </documentManagement>
-</p:properties>
-</file>
-
-<file path=customXml/item2.xml><?xml version="1.0" encoding="utf-8"?>
 <ct:contentTypeSchema xmlns:ct="http://schemas.microsoft.com/office/2006/metadata/contentType" xmlns:ma="http://schemas.microsoft.com/office/2006/metadata/properties/metaAttributes" ct:_="" ma:_="" ma:contentTypeName="Document" ma:contentTypeID="0x0101008E645426CC3C3348B900E57479C898EF" ma:contentTypeVersion="15" ma:contentTypeDescription="Create a new document." ma:contentTypeScope="" ma:versionID="4bc64779f88d1d78707623c1e29ebd00">
   <xsd:schema xmlns:xsd="http://www.w3.org/2001/XMLSchema" xmlns:xs="http://www.w3.org/2001/XMLSchema" xmlns:p="http://schemas.microsoft.com/office/2006/metadata/properties" xmlns:ns3="cc328e4a-acc5-4db9-8edf-03a7e14d7082" xmlns:ns4="5a361508-a8bd-49ac-aae1-a5acde08ec86" targetNamespace="http://schemas.microsoft.com/office/2006/metadata/properties" ma:root="true" ma:fieldsID="3d4d223e92318e0d0dc86e292859e212" ns3:_="" ns4:_="">
     <xsd:import namespace="cc328e4a-acc5-4db9-8edf-03a7e14d7082"/>
@@ -31512,6 +31576,14 @@
 </ct:contentTypeSchema>
 </file>
 
+<file path=customXml/item2.xml><?xml version="1.0" encoding="utf-8"?>
+<p:properties xmlns:p="http://schemas.microsoft.com/office/2006/metadata/properties" xmlns:xsi="http://www.w3.org/2001/XMLSchema-instance" xmlns:pc="http://schemas.microsoft.com/office/infopath/2007/PartnerControls">
+  <documentManagement>
+    <_activity xmlns="cc328e4a-acc5-4db9-8edf-03a7e14d7082" xsi:nil="true"/>
+  </documentManagement>
+</p:properties>
+</file>
+
 <file path=customXml/item3.xml><?xml version="1.0" encoding="utf-8"?>
 <?mso-contentType ?>
 <FormTemplates xmlns="http://schemas.microsoft.com/sharepoint/v3/contenttype/forms">
@@ -31522,18 +31594,6 @@
 </file>
 
 <file path=customXml/itemProps1.xml><?xml version="1.0" encoding="utf-8"?>
-<ds:datastoreItem xmlns:ds="http://schemas.openxmlformats.org/officeDocument/2006/customXml" ds:itemID="{CF4B5514-C2B0-415F-9108-B3264F87DDF2}">
-  <ds:schemaRefs>
-    <ds:schemaRef ds:uri="http://schemas.microsoft.com/office/2006/metadata/properties"/>
-    <ds:schemaRef ds:uri="http://www.w3.org/2000/xmlns/"/>
-    <ds:schemaRef ds:uri="cc328e4a-acc5-4db9-8edf-03a7e14d7082"/>
-    <ds:schemaRef ds:uri="http://www.w3.org/2001/XMLSchema-instance"/>
-    <ds:schemaRef ds:uri="http://schemas.microsoft.com/office/infopath/2007/PartnerControls"/>
-  </ds:schemaRefs>
-</ds:datastoreItem>
-</file>
-
-<file path=customXml/itemProps2.xml><?xml version="1.0" encoding="utf-8"?>
 <ds:datastoreItem xmlns:ds="http://schemas.openxmlformats.org/officeDocument/2006/customXml" ds:itemID="{568CD85B-F839-4F4F-A8A4-47102501B797}">
   <ds:schemaRefs>
     <ds:schemaRef ds:uri="http://schemas.microsoft.com/office/2006/metadata/contentType"/>
@@ -31553,6 +31613,18 @@
 </ds:datastoreItem>
 </file>
 
+<file path=customXml/itemProps2.xml><?xml version="1.0" encoding="utf-8"?>
+<ds:datastoreItem xmlns:ds="http://schemas.openxmlformats.org/officeDocument/2006/customXml" ds:itemID="{CF4B5514-C2B0-415F-9108-B3264F87DDF2}">
+  <ds:schemaRefs>
+    <ds:schemaRef ds:uri="http://schemas.microsoft.com/office/2006/metadata/properties"/>
+    <ds:schemaRef ds:uri="http://www.w3.org/2000/xmlns/"/>
+    <ds:schemaRef ds:uri="cc328e4a-acc5-4db9-8edf-03a7e14d7082"/>
+    <ds:schemaRef ds:uri="http://www.w3.org/2001/XMLSchema-instance"/>
+    <ds:schemaRef ds:uri="http://schemas.microsoft.com/office/infopath/2007/PartnerControls"/>
+  </ds:schemaRefs>
+</ds:datastoreItem>
+</file>
+
 <file path=customXml/itemProps3.xml><?xml version="1.0" encoding="utf-8"?>
 <ds:datastoreItem xmlns:ds="http://schemas.openxmlformats.org/officeDocument/2006/customXml" ds:itemID="{8044CA59-19DA-4472-821C-352737C499D2}">
   <ds:schemaRefs>

</xml_diff>